<commit_message>
Documentation, club delete member fix
</commit_message>
<xml_diff>
--- a/Documentation/Weekly Report/week7/CMSC-4920-Week7-Group2.pptx
+++ b/Documentation/Weekly Report/week7/CMSC-4920-Week7-Group2.pptx
@@ -5,7 +5,7 @@
     <p:sldMasterId id="2147483648" r:id="rId1"/>
   </p:sldMasterIdLst>
   <p:notesMasterIdLst>
-    <p:notesMasterId r:id="rId12"/>
+    <p:notesMasterId r:id="rId14"/>
   </p:notesMasterIdLst>
   <p:sldIdLst>
     <p:sldId id="256" r:id="rId2"/>
@@ -15,9 +15,11 @@
     <p:sldId id="268" r:id="rId6"/>
     <p:sldId id="266" r:id="rId7"/>
     <p:sldId id="258" r:id="rId8"/>
-    <p:sldId id="264" r:id="rId9"/>
-    <p:sldId id="259" r:id="rId10"/>
-    <p:sldId id="260" r:id="rId11"/>
+    <p:sldId id="270" r:id="rId9"/>
+    <p:sldId id="269" r:id="rId10"/>
+    <p:sldId id="264" r:id="rId11"/>
+    <p:sldId id="259" r:id="rId12"/>
+    <p:sldId id="260" r:id="rId13"/>
   </p:sldIdLst>
   <p:sldSz cx="12192000" cy="6858000"/>
   <p:notesSz cx="6858000" cy="9144000"/>
@@ -128,6 +130,7 @@
 <p1510:revInfo xmlns:a="http://schemas.openxmlformats.org/drawingml/2006/main" xmlns:r="http://schemas.openxmlformats.org/officeDocument/2006/relationships" xmlns:p1510="http://schemas.microsoft.com/office/powerpoint/2015/10/main">
   <p1510:revLst>
     <p1510:client id="{9919AF7A-92BB-46C1-950F-B886EA717ED2}" v="7" dt="2026-02-27T16:47:07.449"/>
+    <p1510:client id="{C1454521-8528-4C87-970D-7EAD129946EE}" v="3" dt="2026-02-28T15:48:31.721"/>
     <p1510:client id="{D9D41E03-52DD-4057-9108-ECDA6CA8D6DC}" v="61" dt="2026-02-28T12:25:26.107"/>
   </p1510:revLst>
 </p1510:revInfo>
@@ -137,23 +140,289 @@
 <pc:chgInfo xmlns:a="http://schemas.openxmlformats.org/drawingml/2006/main" xmlns:r="http://schemas.openxmlformats.org/officeDocument/2006/relationships" xmlns:ac="http://schemas.microsoft.com/office/drawing/2013/main/command" xmlns:pc="http://schemas.microsoft.com/office/powerpoint/2013/main/command">
   <pc:docChgLst>
     <pc:chgData name="John Gerega" userId="bd3e1e46fb6a714b" providerId="LiveId" clId="{45F0C402-C550-4C82-B31D-5B32217A5E94}"/>
-    <pc:docChg chg="modSld">
-      <pc:chgData name="John Gerega" userId="bd3e1e46fb6a714b" providerId="LiveId" clId="{45F0C402-C550-4C82-B31D-5B32217A5E94}" dt="2026-02-17T12:42:35.112" v="95" actId="20577"/>
+    <pc:docChg chg="undo custSel addSld delSld modSld sldOrd">
+      <pc:chgData name="John Gerega" userId="bd3e1e46fb6a714b" providerId="LiveId" clId="{45F0C402-C550-4C82-B31D-5B32217A5E94}" dt="2026-02-28T16:05:43.151" v="594" actId="20577"/>
       <pc:docMkLst>
         <pc:docMk/>
       </pc:docMkLst>
       <pc:sldChg chg="modSp mod">
-        <pc:chgData name="John Gerega" userId="bd3e1e46fb6a714b" providerId="LiveId" clId="{45F0C402-C550-4C82-B31D-5B32217A5E94}" dt="2026-02-17T12:42:35.112" v="95" actId="20577"/>
+        <pc:chgData name="John Gerega" userId="bd3e1e46fb6a714b" providerId="LiveId" clId="{45F0C402-C550-4C82-B31D-5B32217A5E94}" dt="2026-02-28T16:05:43.151" v="594" actId="20577"/>
+        <pc:sldMkLst>
+          <pc:docMk/>
+          <pc:sldMk cId="2561402868" sldId="264"/>
+        </pc:sldMkLst>
+        <pc:graphicFrameChg chg="mod modGraphic">
+          <ac:chgData name="John Gerega" userId="bd3e1e46fb6a714b" providerId="LiveId" clId="{45F0C402-C550-4C82-B31D-5B32217A5E94}" dt="2026-02-28T16:05:43.151" v="594" actId="20577"/>
+          <ac:graphicFrameMkLst>
+            <pc:docMk/>
+            <pc:sldMk cId="2561402868" sldId="264"/>
+            <ac:graphicFrameMk id="27" creationId="{D6B93F0B-FEB0-EDAB-CFE1-A57DEFE97FCD}"/>
+          </ac:graphicFrameMkLst>
+        </pc:graphicFrameChg>
+      </pc:sldChg>
+      <pc:sldChg chg="modSp mod">
+        <pc:chgData name="John Gerega" userId="bd3e1e46fb6a714b" providerId="LiveId" clId="{45F0C402-C550-4C82-B31D-5B32217A5E94}" dt="2026-02-28T15:53:13.859" v="585" actId="20577"/>
         <pc:sldMkLst>
           <pc:docMk/>
           <pc:sldMk cId="2428741132" sldId="265"/>
         </pc:sldMkLst>
+        <pc:spChg chg="mod">
+          <ac:chgData name="John Gerega" userId="bd3e1e46fb6a714b" providerId="LiveId" clId="{45F0C402-C550-4C82-B31D-5B32217A5E94}" dt="2026-02-28T15:53:13.859" v="585" actId="20577"/>
+          <ac:spMkLst>
+            <pc:docMk/>
+            <pc:sldMk cId="2428741132" sldId="265"/>
+            <ac:spMk id="2" creationId="{726ED135-95C1-5462-0C4A-3CB641B9D068}"/>
+          </ac:spMkLst>
+        </pc:spChg>
         <pc:spChg chg="mod">
           <ac:chgData name="John Gerega" userId="bd3e1e46fb6a714b" providerId="LiveId" clId="{45F0C402-C550-4C82-B31D-5B32217A5E94}" dt="2026-02-17T12:42:35.112" v="95" actId="20577"/>
           <ac:spMkLst>
             <pc:docMk/>
             <pc:sldMk cId="2428741132" sldId="265"/>
             <ac:spMk id="8" creationId="{7A067979-B2B3-BD33-28AB-42AF2BBE1977}"/>
+          </ac:spMkLst>
+        </pc:spChg>
+      </pc:sldChg>
+      <pc:sldChg chg="modSp mod">
+        <pc:chgData name="John Gerega" userId="bd3e1e46fb6a714b" providerId="LiveId" clId="{45F0C402-C550-4C82-B31D-5B32217A5E94}" dt="2026-02-28T15:14:33.765" v="230" actId="20577"/>
+        <pc:sldMkLst>
+          <pc:docMk/>
+          <pc:sldMk cId="3526335932" sldId="266"/>
+        </pc:sldMkLst>
+        <pc:spChg chg="mod">
+          <ac:chgData name="John Gerega" userId="bd3e1e46fb6a714b" providerId="LiveId" clId="{45F0C402-C550-4C82-B31D-5B32217A5E94}" dt="2026-02-28T15:14:33.765" v="230" actId="20577"/>
+          <ac:spMkLst>
+            <pc:docMk/>
+            <pc:sldMk cId="3526335932" sldId="266"/>
+            <ac:spMk id="3" creationId="{CCDEAB36-867D-95B6-8834-F42C5B9259D0}"/>
+          </ac:spMkLst>
+        </pc:spChg>
+        <pc:spChg chg="mod">
+          <ac:chgData name="John Gerega" userId="bd3e1e46fb6a714b" providerId="LiveId" clId="{45F0C402-C550-4C82-B31D-5B32217A5E94}" dt="2026-02-28T15:14:22.230" v="200" actId="20577"/>
+          <ac:spMkLst>
+            <pc:docMk/>
+            <pc:sldMk cId="3526335932" sldId="266"/>
+            <ac:spMk id="4" creationId="{86ED9EE4-56A8-6AFD-BE9A-A35D2ABC59A0}"/>
+          </ac:spMkLst>
+        </pc:spChg>
+      </pc:sldChg>
+      <pc:sldChg chg="new del">
+        <pc:chgData name="John Gerega" userId="bd3e1e46fb6a714b" providerId="LiveId" clId="{45F0C402-C550-4C82-B31D-5B32217A5E94}" dt="2026-02-28T15:08:57.999" v="114" actId="2696"/>
+        <pc:sldMkLst>
+          <pc:docMk/>
+          <pc:sldMk cId="783062036" sldId="269"/>
+        </pc:sldMkLst>
+      </pc:sldChg>
+      <pc:sldChg chg="addSp delSp modSp new mod setBg">
+        <pc:chgData name="John Gerega" userId="bd3e1e46fb6a714b" providerId="LiveId" clId="{45F0C402-C550-4C82-B31D-5B32217A5E94}" dt="2026-02-28T15:09:34.297" v="146" actId="26606"/>
+        <pc:sldMkLst>
+          <pc:docMk/>
+          <pc:sldMk cId="3967077253" sldId="269"/>
+        </pc:sldMkLst>
+        <pc:spChg chg="mod">
+          <ac:chgData name="John Gerega" userId="bd3e1e46fb6a714b" providerId="LiveId" clId="{45F0C402-C550-4C82-B31D-5B32217A5E94}" dt="2026-02-28T15:09:34.297" v="146" actId="26606"/>
+          <ac:spMkLst>
+            <pc:docMk/>
+            <pc:sldMk cId="3967077253" sldId="269"/>
+            <ac:spMk id="2" creationId="{287294F0-C177-B508-EF76-D3B280BC1128}"/>
+          </ac:spMkLst>
+        </pc:spChg>
+        <pc:spChg chg="del">
+          <ac:chgData name="John Gerega" userId="bd3e1e46fb6a714b" providerId="LiveId" clId="{45F0C402-C550-4C82-B31D-5B32217A5E94}" dt="2026-02-28T15:09:08.919" v="117" actId="26606"/>
+          <ac:spMkLst>
+            <pc:docMk/>
+            <pc:sldMk cId="3967077253" sldId="269"/>
+            <ac:spMk id="3" creationId="{105073B6-A36B-BBE0-4293-28894131F80F}"/>
+          </ac:spMkLst>
+        </pc:spChg>
+        <pc:spChg chg="add mod">
+          <ac:chgData name="John Gerega" userId="bd3e1e46fb6a714b" providerId="LiveId" clId="{45F0C402-C550-4C82-B31D-5B32217A5E94}" dt="2026-02-28T15:09:32.025" v="144" actId="478"/>
+          <ac:spMkLst>
+            <pc:docMk/>
+            <pc:sldMk cId="3967077253" sldId="269"/>
+            <ac:spMk id="7" creationId="{A5BFE5BE-5B8F-489E-995E-26D694F03CD0}"/>
+          </ac:spMkLst>
+        </pc:spChg>
+        <pc:spChg chg="add del">
+          <ac:chgData name="John Gerega" userId="bd3e1e46fb6a714b" providerId="LiveId" clId="{45F0C402-C550-4C82-B31D-5B32217A5E94}" dt="2026-02-28T15:09:34.297" v="146" actId="26606"/>
+          <ac:spMkLst>
+            <pc:docMk/>
+            <pc:sldMk cId="3967077253" sldId="269"/>
+            <ac:spMk id="10" creationId="{A8384FB5-9ADC-4DDC-881B-597D56F5B15D}"/>
+          </ac:spMkLst>
+        </pc:spChg>
+        <pc:spChg chg="add del">
+          <ac:chgData name="John Gerega" userId="bd3e1e46fb6a714b" providerId="LiveId" clId="{45F0C402-C550-4C82-B31D-5B32217A5E94}" dt="2026-02-28T15:09:34.297" v="146" actId="26606"/>
+          <ac:spMkLst>
+            <pc:docMk/>
+            <pc:sldMk cId="3967077253" sldId="269"/>
+            <ac:spMk id="12" creationId="{91E5A9A7-95C6-4F4F-B00E-C82E07FE62EF}"/>
+          </ac:spMkLst>
+        </pc:spChg>
+        <pc:spChg chg="add del">
+          <ac:chgData name="John Gerega" userId="bd3e1e46fb6a714b" providerId="LiveId" clId="{45F0C402-C550-4C82-B31D-5B32217A5E94}" dt="2026-02-28T15:09:34.297" v="146" actId="26606"/>
+          <ac:spMkLst>
+            <pc:docMk/>
+            <pc:sldMk cId="3967077253" sldId="269"/>
+            <ac:spMk id="14" creationId="{D07DD2DE-F619-49DD-B5E7-03A290FF4ED1}"/>
+          </ac:spMkLst>
+        </pc:spChg>
+        <pc:spChg chg="add del">
+          <ac:chgData name="John Gerega" userId="bd3e1e46fb6a714b" providerId="LiveId" clId="{45F0C402-C550-4C82-B31D-5B32217A5E94}" dt="2026-02-28T15:09:34.297" v="146" actId="26606"/>
+          <ac:spMkLst>
+            <pc:docMk/>
+            <pc:sldMk cId="3967077253" sldId="269"/>
+            <ac:spMk id="16" creationId="{85149191-5F60-4A28-AAFF-039F96B0F3EC}"/>
+          </ac:spMkLst>
+        </pc:spChg>
+        <pc:spChg chg="add del">
+          <ac:chgData name="John Gerega" userId="bd3e1e46fb6a714b" providerId="LiveId" clId="{45F0C402-C550-4C82-B31D-5B32217A5E94}" dt="2026-02-28T15:09:34.297" v="146" actId="26606"/>
+          <ac:spMkLst>
+            <pc:docMk/>
+            <pc:sldMk cId="3967077253" sldId="269"/>
+            <ac:spMk id="18" creationId="{F8260ED5-17F7-4158-B241-D51DD4CF1B7E}"/>
+          </ac:spMkLst>
+        </pc:spChg>
+        <pc:spChg chg="add">
+          <ac:chgData name="John Gerega" userId="bd3e1e46fb6a714b" providerId="LiveId" clId="{45F0C402-C550-4C82-B31D-5B32217A5E94}" dt="2026-02-28T15:09:34.297" v="146" actId="26606"/>
+          <ac:spMkLst>
+            <pc:docMk/>
+            <pc:sldMk cId="3967077253" sldId="269"/>
+            <ac:spMk id="23" creationId="{A8384FB5-9ADC-4DDC-881B-597D56F5B15D}"/>
+          </ac:spMkLst>
+        </pc:spChg>
+        <pc:spChg chg="add">
+          <ac:chgData name="John Gerega" userId="bd3e1e46fb6a714b" providerId="LiveId" clId="{45F0C402-C550-4C82-B31D-5B32217A5E94}" dt="2026-02-28T15:09:34.297" v="146" actId="26606"/>
+          <ac:spMkLst>
+            <pc:docMk/>
+            <pc:sldMk cId="3967077253" sldId="269"/>
+            <ac:spMk id="25" creationId="{91E5A9A7-95C6-4F4F-B00E-C82E07FE62EF}"/>
+          </ac:spMkLst>
+        </pc:spChg>
+        <pc:spChg chg="add">
+          <ac:chgData name="John Gerega" userId="bd3e1e46fb6a714b" providerId="LiveId" clId="{45F0C402-C550-4C82-B31D-5B32217A5E94}" dt="2026-02-28T15:09:34.297" v="146" actId="26606"/>
+          <ac:spMkLst>
+            <pc:docMk/>
+            <pc:sldMk cId="3967077253" sldId="269"/>
+            <ac:spMk id="27" creationId="{D07DD2DE-F619-49DD-B5E7-03A290FF4ED1}"/>
+          </ac:spMkLst>
+        </pc:spChg>
+        <pc:spChg chg="add">
+          <ac:chgData name="John Gerega" userId="bd3e1e46fb6a714b" providerId="LiveId" clId="{45F0C402-C550-4C82-B31D-5B32217A5E94}" dt="2026-02-28T15:09:34.297" v="146" actId="26606"/>
+          <ac:spMkLst>
+            <pc:docMk/>
+            <pc:sldMk cId="3967077253" sldId="269"/>
+            <ac:spMk id="29" creationId="{85149191-5F60-4A28-AAFF-039F96B0F3EC}"/>
+          </ac:spMkLst>
+        </pc:spChg>
+        <pc:picChg chg="add del mod">
+          <ac:chgData name="John Gerega" userId="bd3e1e46fb6a714b" providerId="LiveId" clId="{45F0C402-C550-4C82-B31D-5B32217A5E94}" dt="2026-02-28T15:09:32.025" v="144" actId="478"/>
+          <ac:picMkLst>
+            <pc:docMk/>
+            <pc:sldMk cId="3967077253" sldId="269"/>
+            <ac:picMk id="5" creationId="{A5CA5E0F-E884-11F8-660B-6508D5656633}"/>
+          </ac:picMkLst>
+        </pc:picChg>
+        <pc:picChg chg="add">
+          <ac:chgData name="John Gerega" userId="bd3e1e46fb6a714b" providerId="LiveId" clId="{45F0C402-C550-4C82-B31D-5B32217A5E94}" dt="2026-02-28T15:09:32.453" v="145" actId="22"/>
+          <ac:picMkLst>
+            <pc:docMk/>
+            <pc:sldMk cId="3967077253" sldId="269"/>
+            <ac:picMk id="9" creationId="{D59BCB45-73D7-766D-FD59-D8B09BE25C52}"/>
+          </ac:picMkLst>
+        </pc:picChg>
+      </pc:sldChg>
+      <pc:sldChg chg="addSp delSp modSp add mod ord">
+        <pc:chgData name="John Gerega" userId="bd3e1e46fb6a714b" providerId="LiveId" clId="{45F0C402-C550-4C82-B31D-5B32217A5E94}" dt="2026-02-28T15:16:08.421" v="272" actId="1076"/>
+        <pc:sldMkLst>
+          <pc:docMk/>
+          <pc:sldMk cId="1279643669" sldId="270"/>
+        </pc:sldMkLst>
+        <pc:spChg chg="mod">
+          <ac:chgData name="John Gerega" userId="bd3e1e46fb6a714b" providerId="LiveId" clId="{45F0C402-C550-4C82-B31D-5B32217A5E94}" dt="2026-02-28T15:15:09.057" v="261" actId="20577"/>
+          <ac:spMkLst>
+            <pc:docMk/>
+            <pc:sldMk cId="1279643669" sldId="270"/>
+            <ac:spMk id="2" creationId="{E7ADF079-FAEB-82AB-5AAA-BCCDB807CC00}"/>
+          </ac:spMkLst>
+        </pc:spChg>
+        <pc:spChg chg="add del mod">
+          <ac:chgData name="John Gerega" userId="bd3e1e46fb6a714b" providerId="LiveId" clId="{45F0C402-C550-4C82-B31D-5B32217A5E94}" dt="2026-02-28T15:16:02.765" v="270" actId="478"/>
+          <ac:spMkLst>
+            <pc:docMk/>
+            <pc:sldMk cId="1279643669" sldId="270"/>
+            <ac:spMk id="4" creationId="{02A6D634-AA40-EA7F-5633-86EB03E79233}"/>
+          </ac:spMkLst>
+        </pc:spChg>
+        <pc:picChg chg="add mod">
+          <ac:chgData name="John Gerega" userId="bd3e1e46fb6a714b" providerId="LiveId" clId="{45F0C402-C550-4C82-B31D-5B32217A5E94}" dt="2026-02-28T15:16:05.886" v="271" actId="1076"/>
+          <ac:picMkLst>
+            <pc:docMk/>
+            <pc:sldMk cId="1279643669" sldId="270"/>
+            <ac:picMk id="6" creationId="{6BE273B2-F117-7B45-075E-81A1E11AEF51}"/>
+          </ac:picMkLst>
+        </pc:picChg>
+        <pc:picChg chg="add mod">
+          <ac:chgData name="John Gerega" userId="bd3e1e46fb6a714b" providerId="LiveId" clId="{45F0C402-C550-4C82-B31D-5B32217A5E94}" dt="2026-02-28T15:16:08.421" v="272" actId="1076"/>
+          <ac:picMkLst>
+            <pc:docMk/>
+            <pc:sldMk cId="1279643669" sldId="270"/>
+            <ac:picMk id="8" creationId="{A9A65ADA-C7D0-4668-D0C0-B864E947F509}"/>
+          </ac:picMkLst>
+        </pc:picChg>
+        <pc:picChg chg="del">
+          <ac:chgData name="John Gerega" userId="bd3e1e46fb6a714b" providerId="LiveId" clId="{45F0C402-C550-4C82-B31D-5B32217A5E94}" dt="2026-02-28T15:15:11.239" v="262" actId="478"/>
+          <ac:picMkLst>
+            <pc:docMk/>
+            <pc:sldMk cId="1279643669" sldId="270"/>
+            <ac:picMk id="9" creationId="{298B8233-C201-16C0-9230-E1276A7195E7}"/>
+          </ac:picMkLst>
+        </pc:picChg>
+      </pc:sldChg>
+      <pc:sldChg chg="addSp delSp add del setBg delDesignElem">
+        <pc:chgData name="John Gerega" userId="bd3e1e46fb6a714b" providerId="LiveId" clId="{45F0C402-C550-4C82-B31D-5B32217A5E94}" dt="2026-02-28T15:14:55.297" v="233"/>
+        <pc:sldMkLst>
+          <pc:docMk/>
+          <pc:sldMk cId="2437964280" sldId="270"/>
+        </pc:sldMkLst>
+        <pc:spChg chg="add del">
+          <ac:chgData name="John Gerega" userId="bd3e1e46fb6a714b" providerId="LiveId" clId="{45F0C402-C550-4C82-B31D-5B32217A5E94}" dt="2026-02-28T15:14:55.297" v="233"/>
+          <ac:spMkLst>
+            <pc:docMk/>
+            <pc:sldMk cId="2437964280" sldId="270"/>
+            <ac:spMk id="23" creationId="{55D4403E-316A-B2F8-3440-27AF87E6C0AA}"/>
+          </ac:spMkLst>
+        </pc:spChg>
+        <pc:spChg chg="add del">
+          <ac:chgData name="John Gerega" userId="bd3e1e46fb6a714b" providerId="LiveId" clId="{45F0C402-C550-4C82-B31D-5B32217A5E94}" dt="2026-02-28T15:14:55.297" v="233"/>
+          <ac:spMkLst>
+            <pc:docMk/>
+            <pc:sldMk cId="2437964280" sldId="270"/>
+            <ac:spMk id="25" creationId="{2B692B7E-A234-07BD-1260-9CB37235924F}"/>
+          </ac:spMkLst>
+        </pc:spChg>
+        <pc:spChg chg="add del">
+          <ac:chgData name="John Gerega" userId="bd3e1e46fb6a714b" providerId="LiveId" clId="{45F0C402-C550-4C82-B31D-5B32217A5E94}" dt="2026-02-28T15:14:55.297" v="233"/>
+          <ac:spMkLst>
+            <pc:docMk/>
+            <pc:sldMk cId="2437964280" sldId="270"/>
+            <ac:spMk id="27" creationId="{CA81E4F4-3BE1-6D09-222B-4C92CA62E8DD}"/>
+          </ac:spMkLst>
+        </pc:spChg>
+        <pc:spChg chg="add del">
+          <ac:chgData name="John Gerega" userId="bd3e1e46fb6a714b" providerId="LiveId" clId="{45F0C402-C550-4C82-B31D-5B32217A5E94}" dt="2026-02-28T15:14:55.297" v="233"/>
+          <ac:spMkLst>
+            <pc:docMk/>
+            <pc:sldMk cId="2437964280" sldId="270"/>
+            <ac:spMk id="29" creationId="{6C201988-A86B-65A2-F372-DD960F35AD20}"/>
+          </ac:spMkLst>
+        </pc:spChg>
+        <pc:spChg chg="add del">
+          <ac:chgData name="John Gerega" userId="bd3e1e46fb6a714b" providerId="LiveId" clId="{45F0C402-C550-4C82-B31D-5B32217A5E94}" dt="2026-02-28T15:14:55.297" v="233"/>
+          <ac:spMkLst>
+            <pc:docMk/>
+            <pc:sldMk cId="2437964280" sldId="270"/>
+            <ac:spMk id="31" creationId="{B43BB295-49A6-F775-A17E-705AFBDDA127}"/>
           </ac:spMkLst>
         </pc:spChg>
       </pc:sldChg>
@@ -3281,7 +3550,10 @@
         <a:bodyPr/>
         <a:lstStyle/>
         <a:p>
-          <a:endParaRPr lang="en-US" dirty="0"/>
+          <a:r>
+            <a:rPr lang="en-US" dirty="0"/>
+            <a:t>Fix Email Backend issue</a:t>
+          </a:r>
         </a:p>
       </dgm:t>
     </dgm:pt>
@@ -3314,7 +3586,10 @@
         <a:bodyPr/>
         <a:lstStyle/>
         <a:p>
-          <a:endParaRPr lang="en-US" dirty="0"/>
+          <a:r>
+            <a:rPr lang="en-US" dirty="0"/>
+            <a:t>User Profile Section</a:t>
+          </a:r>
         </a:p>
       </dgm:t>
     </dgm:pt>
@@ -3347,7 +3622,10 @@
         <a:bodyPr/>
         <a:lstStyle/>
         <a:p>
-          <a:endParaRPr lang="en-US" dirty="0"/>
+          <a:r>
+            <a:rPr lang="en-US" dirty="0"/>
+            <a:t>Continue development on other pages</a:t>
+          </a:r>
         </a:p>
       </dgm:t>
     </dgm:pt>
@@ -3363,6 +3641,43 @@
       </dgm:t>
     </dgm:pt>
     <dgm:pt modelId="{2E6446DA-01C1-4120-833E-FA0E55DC486E}" type="sibTrans" cxnId="{1D79B17F-FF0A-433C-AD09-31B22D2982FD}">
+      <dgm:prSet/>
+      <dgm:spPr/>
+      <dgm:t>
+        <a:bodyPr/>
+        <a:lstStyle/>
+        <a:p>
+          <a:endParaRPr lang="en-US"/>
+        </a:p>
+      </dgm:t>
+    </dgm:pt>
+    <dgm:pt modelId="{5C97C9DE-9495-4428-A64F-575877D17861}">
+      <dgm:prSet/>
+      <dgm:spPr/>
+      <dgm:t>
+        <a:bodyPr/>
+        <a:lstStyle/>
+        <a:p>
+          <a:r>
+            <a:rPr lang="en-US"/>
+            <a:t>Maps Page</a:t>
+          </a:r>
+          <a:endParaRPr lang="en-US" dirty="0"/>
+        </a:p>
+      </dgm:t>
+    </dgm:pt>
+    <dgm:pt modelId="{E1FDFEE7-F3D0-4616-BD9A-97B31F862CF5}" type="parTrans" cxnId="{0CE1AD55-6551-40EB-B176-1426812654BA}">
+      <dgm:prSet/>
+      <dgm:spPr/>
+      <dgm:t>
+        <a:bodyPr/>
+        <a:lstStyle/>
+        <a:p>
+          <a:endParaRPr lang="en-US"/>
+        </a:p>
+      </dgm:t>
+    </dgm:pt>
+    <dgm:pt modelId="{146C9FFB-5F77-4C2A-A1E4-F65674AF3584}" type="sibTrans" cxnId="{0CE1AD55-6551-40EB-B176-1426812654BA}">
       <dgm:prSet/>
       <dgm:spPr/>
       <dgm:t>
@@ -3394,11 +3709,11 @@
       <dgm:spPr/>
     </dgm:pt>
     <dgm:pt modelId="{98190555-19A4-4CFA-B5ED-89857792E0B9}" type="pres">
-      <dgm:prSet presAssocID="{7D77D55D-8CCB-40C4-94CB-4B06CD8B8779}" presName="background" presStyleLbl="node0" presStyleIdx="0" presStyleCnt="3"/>
+      <dgm:prSet presAssocID="{7D77D55D-8CCB-40C4-94CB-4B06CD8B8779}" presName="background" presStyleLbl="node0" presStyleIdx="0" presStyleCnt="4"/>
       <dgm:spPr/>
     </dgm:pt>
     <dgm:pt modelId="{1183B01D-027F-4222-9A5D-26614D621D81}" type="pres">
-      <dgm:prSet presAssocID="{7D77D55D-8CCB-40C4-94CB-4B06CD8B8779}" presName="text" presStyleLbl="fgAcc0" presStyleIdx="0" presStyleCnt="3">
+      <dgm:prSet presAssocID="{7D77D55D-8CCB-40C4-94CB-4B06CD8B8779}" presName="text" presStyleLbl="fgAcc0" presStyleIdx="0" presStyleCnt="4">
         <dgm:presLayoutVars>
           <dgm:chPref val="3"/>
         </dgm:presLayoutVars>
@@ -3418,11 +3733,11 @@
       <dgm:spPr/>
     </dgm:pt>
     <dgm:pt modelId="{FE1BC2AB-A6F4-451D-B5E4-EBBE2F580413}" type="pres">
-      <dgm:prSet presAssocID="{9C35D664-F4ED-4924-B85E-A22D43967662}" presName="background" presStyleLbl="node0" presStyleIdx="1" presStyleCnt="3"/>
+      <dgm:prSet presAssocID="{9C35D664-F4ED-4924-B85E-A22D43967662}" presName="background" presStyleLbl="node0" presStyleIdx="1" presStyleCnt="4"/>
       <dgm:spPr/>
     </dgm:pt>
     <dgm:pt modelId="{EE8EEF36-F451-494C-9D0C-6D4B4B602222}" type="pres">
-      <dgm:prSet presAssocID="{9C35D664-F4ED-4924-B85E-A22D43967662}" presName="text" presStyleLbl="fgAcc0" presStyleIdx="1" presStyleCnt="3">
+      <dgm:prSet presAssocID="{9C35D664-F4ED-4924-B85E-A22D43967662}" presName="text" presStyleLbl="fgAcc0" presStyleIdx="1" presStyleCnt="4">
         <dgm:presLayoutVars>
           <dgm:chPref val="3"/>
         </dgm:presLayoutVars>
@@ -3442,11 +3757,11 @@
       <dgm:spPr/>
     </dgm:pt>
     <dgm:pt modelId="{CA2C5924-FEEE-41E7-8498-90F97462AB60}" type="pres">
-      <dgm:prSet presAssocID="{D164FE33-84B1-4569-B205-B8D56A463CA2}" presName="background" presStyleLbl="node0" presStyleIdx="2" presStyleCnt="3"/>
+      <dgm:prSet presAssocID="{D164FE33-84B1-4569-B205-B8D56A463CA2}" presName="background" presStyleLbl="node0" presStyleIdx="2" presStyleCnt="4"/>
       <dgm:spPr/>
     </dgm:pt>
     <dgm:pt modelId="{464A5E94-15C8-483E-96F7-DE1ACC400150}" type="pres">
-      <dgm:prSet presAssocID="{D164FE33-84B1-4569-B205-B8D56A463CA2}" presName="text" presStyleLbl="fgAcc0" presStyleIdx="2" presStyleCnt="3">
+      <dgm:prSet presAssocID="{D164FE33-84B1-4569-B205-B8D56A463CA2}" presName="text" presStyleLbl="fgAcc0" presStyleIdx="2" presStyleCnt="4">
         <dgm:presLayoutVars>
           <dgm:chPref val="3"/>
         </dgm:presLayoutVars>
@@ -3457,30 +3772,61 @@
       <dgm:prSet presAssocID="{D164FE33-84B1-4569-B205-B8D56A463CA2}" presName="hierChild2" presStyleCnt="0"/>
       <dgm:spPr/>
     </dgm:pt>
+    <dgm:pt modelId="{1A392811-0146-4262-8761-79D23D35FC2D}" type="pres">
+      <dgm:prSet presAssocID="{5C97C9DE-9495-4428-A64F-575877D17861}" presName="hierRoot1" presStyleCnt="0"/>
+      <dgm:spPr/>
+    </dgm:pt>
+    <dgm:pt modelId="{145D3C01-256A-48D0-A78E-9E6214B221ED}" type="pres">
+      <dgm:prSet presAssocID="{5C97C9DE-9495-4428-A64F-575877D17861}" presName="composite" presStyleCnt="0"/>
+      <dgm:spPr/>
+    </dgm:pt>
+    <dgm:pt modelId="{45E38DED-5226-4ACC-AAA7-64518879BBE1}" type="pres">
+      <dgm:prSet presAssocID="{5C97C9DE-9495-4428-A64F-575877D17861}" presName="background" presStyleLbl="node0" presStyleIdx="3" presStyleCnt="4"/>
+      <dgm:spPr/>
+    </dgm:pt>
+    <dgm:pt modelId="{CC3079B4-CEB8-414A-ACEE-D2B104993680}" type="pres">
+      <dgm:prSet presAssocID="{5C97C9DE-9495-4428-A64F-575877D17861}" presName="text" presStyleLbl="fgAcc0" presStyleIdx="3" presStyleCnt="4">
+        <dgm:presLayoutVars>
+          <dgm:chPref val="3"/>
+        </dgm:presLayoutVars>
+      </dgm:prSet>
+      <dgm:spPr/>
+    </dgm:pt>
+    <dgm:pt modelId="{2B9E0F56-27B1-4331-8049-934533AC2955}" type="pres">
+      <dgm:prSet presAssocID="{5C97C9DE-9495-4428-A64F-575877D17861}" presName="hierChild2" presStyleCnt="0"/>
+      <dgm:spPr/>
+    </dgm:pt>
   </dgm:ptLst>
   <dgm:cxnLst>
-    <dgm:cxn modelId="{05C86F0A-4746-460B-9098-72321F3CDD33}" type="presOf" srcId="{D164FE33-84B1-4569-B205-B8D56A463CA2}" destId="{464A5E94-15C8-483E-96F7-DE1ACC400150}" srcOrd="0" destOrd="0" presId="urn:microsoft.com/office/officeart/2005/8/layout/hierarchy1"/>
+    <dgm:cxn modelId="{66C80707-24F5-4682-9A8A-C5E58C7BB3D0}" type="presOf" srcId="{7D77D55D-8CCB-40C4-94CB-4B06CD8B8779}" destId="{1183B01D-027F-4222-9A5D-26614D621D81}" srcOrd="0" destOrd="0" presId="urn:microsoft.com/office/officeart/2005/8/layout/hierarchy1"/>
     <dgm:cxn modelId="{A836B724-0D4D-49B8-8C7E-FE8E2C59804C}" srcId="{875220B3-5F43-41BF-82F0-F1D5090E78B1}" destId="{7D77D55D-8CCB-40C4-94CB-4B06CD8B8779}" srcOrd="0" destOrd="0" parTransId="{6A9C7EF0-5CCC-409B-8130-14FC63A16319}" sibTransId="{3EAD9D27-CDC1-4D2B-8EDB-51D7B39371E6}"/>
     <dgm:cxn modelId="{BC06C170-83F3-4F9D-8D58-ADC0D316C39A}" type="presOf" srcId="{875220B3-5F43-41BF-82F0-F1D5090E78B1}" destId="{F85EEB6F-AAF0-4C94-BC92-C847D8A79108}" srcOrd="0" destOrd="0" presId="urn:microsoft.com/office/officeart/2005/8/layout/hierarchy1"/>
-    <dgm:cxn modelId="{01442F58-BA90-4E63-BCA2-075C3C0378F0}" type="presOf" srcId="{7D77D55D-8CCB-40C4-94CB-4B06CD8B8779}" destId="{1183B01D-027F-4222-9A5D-26614D621D81}" srcOrd="0" destOrd="0" presId="urn:microsoft.com/office/officeart/2005/8/layout/hierarchy1"/>
+    <dgm:cxn modelId="{0CE1AD55-6551-40EB-B176-1426812654BA}" srcId="{875220B3-5F43-41BF-82F0-F1D5090E78B1}" destId="{5C97C9DE-9495-4428-A64F-575877D17861}" srcOrd="3" destOrd="0" parTransId="{E1FDFEE7-F3D0-4616-BD9A-97B31F862CF5}" sibTransId="{146C9FFB-5F77-4C2A-A1E4-F65674AF3584}"/>
     <dgm:cxn modelId="{1D79B17F-FF0A-433C-AD09-31B22D2982FD}" srcId="{875220B3-5F43-41BF-82F0-F1D5090E78B1}" destId="{D164FE33-84B1-4569-B205-B8D56A463CA2}" srcOrd="2" destOrd="0" parTransId="{7DA97775-1858-48FE-BDF4-3C1835F95D31}" sibTransId="{2E6446DA-01C1-4120-833E-FA0E55DC486E}"/>
-    <dgm:cxn modelId="{5B786AAC-222A-4468-B55B-0EAA368993A2}" type="presOf" srcId="{9C35D664-F4ED-4924-B85E-A22D43967662}" destId="{EE8EEF36-F451-494C-9D0C-6D4B4B602222}" srcOrd="0" destOrd="0" presId="urn:microsoft.com/office/officeart/2005/8/layout/hierarchy1"/>
+    <dgm:cxn modelId="{176D2593-FB8E-482F-AA33-5DDF8D5040D9}" type="presOf" srcId="{9C35D664-F4ED-4924-B85E-A22D43967662}" destId="{EE8EEF36-F451-494C-9D0C-6D4B4B602222}" srcOrd="0" destOrd="0" presId="urn:microsoft.com/office/officeart/2005/8/layout/hierarchy1"/>
+    <dgm:cxn modelId="{4A20AEC2-BD6D-409B-A94B-A9094EA1645A}" type="presOf" srcId="{5C97C9DE-9495-4428-A64F-575877D17861}" destId="{CC3079B4-CEB8-414A-ACEE-D2B104993680}" srcOrd="0" destOrd="0" presId="urn:microsoft.com/office/officeart/2005/8/layout/hierarchy1"/>
     <dgm:cxn modelId="{96D4C5E8-25DD-4F37-89A6-060DD8940082}" srcId="{875220B3-5F43-41BF-82F0-F1D5090E78B1}" destId="{9C35D664-F4ED-4924-B85E-A22D43967662}" srcOrd="1" destOrd="0" parTransId="{C36022C4-2A61-4049-9E7C-3331704CC85B}" sibTransId="{8166ABFB-FA54-4D42-B19D-457B349DE33D}"/>
-    <dgm:cxn modelId="{95049FAD-31F9-439F-BFA3-E22A1A563604}" type="presParOf" srcId="{F85EEB6F-AAF0-4C94-BC92-C847D8A79108}" destId="{1B7C8F59-19C7-4811-ACF5-94E83EF18D53}" srcOrd="0" destOrd="0" presId="urn:microsoft.com/office/officeart/2005/8/layout/hierarchy1"/>
-    <dgm:cxn modelId="{1E3A4A04-0C1F-470B-B4ED-DC851A10E818}" type="presParOf" srcId="{1B7C8F59-19C7-4811-ACF5-94E83EF18D53}" destId="{8918ADED-6A57-4174-8DFD-B8853753C67B}" srcOrd="0" destOrd="0" presId="urn:microsoft.com/office/officeart/2005/8/layout/hierarchy1"/>
-    <dgm:cxn modelId="{1BC6797F-EB63-43BF-AFEA-D0146C2A2E21}" type="presParOf" srcId="{8918ADED-6A57-4174-8DFD-B8853753C67B}" destId="{98190555-19A4-4CFA-B5ED-89857792E0B9}" srcOrd="0" destOrd="0" presId="urn:microsoft.com/office/officeart/2005/8/layout/hierarchy1"/>
-    <dgm:cxn modelId="{1F7CD6F7-51FF-4138-B0CC-42CF8E0CFE06}" type="presParOf" srcId="{8918ADED-6A57-4174-8DFD-B8853753C67B}" destId="{1183B01D-027F-4222-9A5D-26614D621D81}" srcOrd="1" destOrd="0" presId="urn:microsoft.com/office/officeart/2005/8/layout/hierarchy1"/>
-    <dgm:cxn modelId="{43663621-4EB7-4D21-A7EA-406D22B380E8}" type="presParOf" srcId="{1B7C8F59-19C7-4811-ACF5-94E83EF18D53}" destId="{769B866C-995B-4621-BF4F-632E3E797DE6}" srcOrd="1" destOrd="0" presId="urn:microsoft.com/office/officeart/2005/8/layout/hierarchy1"/>
-    <dgm:cxn modelId="{70C13F18-7581-4BC8-894F-491B57EE2C69}" type="presParOf" srcId="{F85EEB6F-AAF0-4C94-BC92-C847D8A79108}" destId="{7C0E07B7-20A4-4341-8762-1E58F807E8BA}" srcOrd="1" destOrd="0" presId="urn:microsoft.com/office/officeart/2005/8/layout/hierarchy1"/>
-    <dgm:cxn modelId="{78DBC6C1-73C1-4548-A4BC-FA3047F5A73B}" type="presParOf" srcId="{7C0E07B7-20A4-4341-8762-1E58F807E8BA}" destId="{167A3E1F-AD74-4598-B50A-3C9D400D900E}" srcOrd="0" destOrd="0" presId="urn:microsoft.com/office/officeart/2005/8/layout/hierarchy1"/>
-    <dgm:cxn modelId="{FD8996CB-5238-43A3-BEAB-80F1A6BFE21B}" type="presParOf" srcId="{167A3E1F-AD74-4598-B50A-3C9D400D900E}" destId="{FE1BC2AB-A6F4-451D-B5E4-EBBE2F580413}" srcOrd="0" destOrd="0" presId="urn:microsoft.com/office/officeart/2005/8/layout/hierarchy1"/>
-    <dgm:cxn modelId="{CBA5D3B1-A39D-49FA-8BB0-FA4491539200}" type="presParOf" srcId="{167A3E1F-AD74-4598-B50A-3C9D400D900E}" destId="{EE8EEF36-F451-494C-9D0C-6D4B4B602222}" srcOrd="1" destOrd="0" presId="urn:microsoft.com/office/officeart/2005/8/layout/hierarchy1"/>
-    <dgm:cxn modelId="{72142E2E-2D64-41DE-B594-BAA603395FD6}" type="presParOf" srcId="{7C0E07B7-20A4-4341-8762-1E58F807E8BA}" destId="{7BE69AD2-283F-47B6-B4ED-6AF7473EBC65}" srcOrd="1" destOrd="0" presId="urn:microsoft.com/office/officeart/2005/8/layout/hierarchy1"/>
-    <dgm:cxn modelId="{93F6E5D4-69E2-4BA3-B007-DA99ED72255F}" type="presParOf" srcId="{F85EEB6F-AAF0-4C94-BC92-C847D8A79108}" destId="{5654D2F3-0BB4-4E47-B368-909288A5B2BD}" srcOrd="2" destOrd="0" presId="urn:microsoft.com/office/officeart/2005/8/layout/hierarchy1"/>
-    <dgm:cxn modelId="{6120C75B-3644-4B15-9344-967D4E7D8A4A}" type="presParOf" srcId="{5654D2F3-0BB4-4E47-B368-909288A5B2BD}" destId="{CD50A866-77B7-46A1-AFBB-CAE16E141989}" srcOrd="0" destOrd="0" presId="urn:microsoft.com/office/officeart/2005/8/layout/hierarchy1"/>
-    <dgm:cxn modelId="{1708E196-57E8-4C6E-9527-BA3E576C7203}" type="presParOf" srcId="{CD50A866-77B7-46A1-AFBB-CAE16E141989}" destId="{CA2C5924-FEEE-41E7-8498-90F97462AB60}" srcOrd="0" destOrd="0" presId="urn:microsoft.com/office/officeart/2005/8/layout/hierarchy1"/>
-    <dgm:cxn modelId="{DEFC47D3-F17C-4128-8087-EBC594B8A1E7}" type="presParOf" srcId="{CD50A866-77B7-46A1-AFBB-CAE16E141989}" destId="{464A5E94-15C8-483E-96F7-DE1ACC400150}" srcOrd="1" destOrd="0" presId="urn:microsoft.com/office/officeart/2005/8/layout/hierarchy1"/>
-    <dgm:cxn modelId="{3136D6E1-4AB0-4735-839A-F019FBC2E0A6}" type="presParOf" srcId="{5654D2F3-0BB4-4E47-B368-909288A5B2BD}" destId="{E1C6EDBD-8470-4060-92F8-D31F6A8051C0}" srcOrd="1" destOrd="0" presId="urn:microsoft.com/office/officeart/2005/8/layout/hierarchy1"/>
+    <dgm:cxn modelId="{1392CCF0-FC8A-4C4C-8B69-734F40574D14}" type="presOf" srcId="{D164FE33-84B1-4569-B205-B8D56A463CA2}" destId="{464A5E94-15C8-483E-96F7-DE1ACC400150}" srcOrd="0" destOrd="0" presId="urn:microsoft.com/office/officeart/2005/8/layout/hierarchy1"/>
+    <dgm:cxn modelId="{01649F12-1BD6-4C2C-89A4-CFE7E333F9CF}" type="presParOf" srcId="{F85EEB6F-AAF0-4C94-BC92-C847D8A79108}" destId="{1B7C8F59-19C7-4811-ACF5-94E83EF18D53}" srcOrd="0" destOrd="0" presId="urn:microsoft.com/office/officeart/2005/8/layout/hierarchy1"/>
+    <dgm:cxn modelId="{A314521F-BA19-4579-9A48-D2E934E1FF31}" type="presParOf" srcId="{1B7C8F59-19C7-4811-ACF5-94E83EF18D53}" destId="{8918ADED-6A57-4174-8DFD-B8853753C67B}" srcOrd="0" destOrd="0" presId="urn:microsoft.com/office/officeart/2005/8/layout/hierarchy1"/>
+    <dgm:cxn modelId="{6916FB5B-39B8-4EA3-83C9-0C86F5F7BE2F}" type="presParOf" srcId="{8918ADED-6A57-4174-8DFD-B8853753C67B}" destId="{98190555-19A4-4CFA-B5ED-89857792E0B9}" srcOrd="0" destOrd="0" presId="urn:microsoft.com/office/officeart/2005/8/layout/hierarchy1"/>
+    <dgm:cxn modelId="{8C08263C-C809-4394-83BF-74040C874CD4}" type="presParOf" srcId="{8918ADED-6A57-4174-8DFD-B8853753C67B}" destId="{1183B01D-027F-4222-9A5D-26614D621D81}" srcOrd="1" destOrd="0" presId="urn:microsoft.com/office/officeart/2005/8/layout/hierarchy1"/>
+    <dgm:cxn modelId="{E2F1B48C-A965-4AB5-B094-77A8B6CD6D51}" type="presParOf" srcId="{1B7C8F59-19C7-4811-ACF5-94E83EF18D53}" destId="{769B866C-995B-4621-BF4F-632E3E797DE6}" srcOrd="1" destOrd="0" presId="urn:microsoft.com/office/officeart/2005/8/layout/hierarchy1"/>
+    <dgm:cxn modelId="{A592AF79-D520-4991-85FC-DBB8DCFBC0A7}" type="presParOf" srcId="{F85EEB6F-AAF0-4C94-BC92-C847D8A79108}" destId="{7C0E07B7-20A4-4341-8762-1E58F807E8BA}" srcOrd="1" destOrd="0" presId="urn:microsoft.com/office/officeart/2005/8/layout/hierarchy1"/>
+    <dgm:cxn modelId="{56FA8E76-F67A-482A-B107-AA13883A5CBC}" type="presParOf" srcId="{7C0E07B7-20A4-4341-8762-1E58F807E8BA}" destId="{167A3E1F-AD74-4598-B50A-3C9D400D900E}" srcOrd="0" destOrd="0" presId="urn:microsoft.com/office/officeart/2005/8/layout/hierarchy1"/>
+    <dgm:cxn modelId="{14150A9E-7CC0-4811-957A-131E4B9B2627}" type="presParOf" srcId="{167A3E1F-AD74-4598-B50A-3C9D400D900E}" destId="{FE1BC2AB-A6F4-451D-B5E4-EBBE2F580413}" srcOrd="0" destOrd="0" presId="urn:microsoft.com/office/officeart/2005/8/layout/hierarchy1"/>
+    <dgm:cxn modelId="{99EDCC81-F193-4332-A323-8BCBECC681EA}" type="presParOf" srcId="{167A3E1F-AD74-4598-B50A-3C9D400D900E}" destId="{EE8EEF36-F451-494C-9D0C-6D4B4B602222}" srcOrd="1" destOrd="0" presId="urn:microsoft.com/office/officeart/2005/8/layout/hierarchy1"/>
+    <dgm:cxn modelId="{42BAF63D-4FB1-4BEC-8C69-B10C7C60B6D8}" type="presParOf" srcId="{7C0E07B7-20A4-4341-8762-1E58F807E8BA}" destId="{7BE69AD2-283F-47B6-B4ED-6AF7473EBC65}" srcOrd="1" destOrd="0" presId="urn:microsoft.com/office/officeart/2005/8/layout/hierarchy1"/>
+    <dgm:cxn modelId="{7F19D7A8-5BB8-4789-ABC9-C33AB90464AD}" type="presParOf" srcId="{F85EEB6F-AAF0-4C94-BC92-C847D8A79108}" destId="{5654D2F3-0BB4-4E47-B368-909288A5B2BD}" srcOrd="2" destOrd="0" presId="urn:microsoft.com/office/officeart/2005/8/layout/hierarchy1"/>
+    <dgm:cxn modelId="{E3A10F56-6D77-45F9-BFCB-83E8E9B6E8B5}" type="presParOf" srcId="{5654D2F3-0BB4-4E47-B368-909288A5B2BD}" destId="{CD50A866-77B7-46A1-AFBB-CAE16E141989}" srcOrd="0" destOrd="0" presId="urn:microsoft.com/office/officeart/2005/8/layout/hierarchy1"/>
+    <dgm:cxn modelId="{D226901A-2956-4DBB-A182-6E1143E273A0}" type="presParOf" srcId="{CD50A866-77B7-46A1-AFBB-CAE16E141989}" destId="{CA2C5924-FEEE-41E7-8498-90F97462AB60}" srcOrd="0" destOrd="0" presId="urn:microsoft.com/office/officeart/2005/8/layout/hierarchy1"/>
+    <dgm:cxn modelId="{49EDF596-AA71-47CD-B57D-900FC8DF86FC}" type="presParOf" srcId="{CD50A866-77B7-46A1-AFBB-CAE16E141989}" destId="{464A5E94-15C8-483E-96F7-DE1ACC400150}" srcOrd="1" destOrd="0" presId="urn:microsoft.com/office/officeart/2005/8/layout/hierarchy1"/>
+    <dgm:cxn modelId="{AABCF0AE-231C-46DF-B4EC-05B340161826}" type="presParOf" srcId="{5654D2F3-0BB4-4E47-B368-909288A5B2BD}" destId="{E1C6EDBD-8470-4060-92F8-D31F6A8051C0}" srcOrd="1" destOrd="0" presId="urn:microsoft.com/office/officeart/2005/8/layout/hierarchy1"/>
+    <dgm:cxn modelId="{102BF11B-867E-4F23-B762-FEB33B9EF6E8}" type="presParOf" srcId="{F85EEB6F-AAF0-4C94-BC92-C847D8A79108}" destId="{1A392811-0146-4262-8761-79D23D35FC2D}" srcOrd="3" destOrd="0" presId="urn:microsoft.com/office/officeart/2005/8/layout/hierarchy1"/>
+    <dgm:cxn modelId="{C15078F8-7781-412C-89A2-C7DA9340A15A}" type="presParOf" srcId="{1A392811-0146-4262-8761-79D23D35FC2D}" destId="{145D3C01-256A-48D0-A78E-9E6214B221ED}" srcOrd="0" destOrd="0" presId="urn:microsoft.com/office/officeart/2005/8/layout/hierarchy1"/>
+    <dgm:cxn modelId="{15ACE16D-1A56-499D-B2E6-46BBFDDF66E1}" type="presParOf" srcId="{145D3C01-256A-48D0-A78E-9E6214B221ED}" destId="{45E38DED-5226-4ACC-AAA7-64518879BBE1}" srcOrd="0" destOrd="0" presId="urn:microsoft.com/office/officeart/2005/8/layout/hierarchy1"/>
+    <dgm:cxn modelId="{28B3BB58-13B7-4A99-81D8-4542C800200E}" type="presParOf" srcId="{145D3C01-256A-48D0-A78E-9E6214B221ED}" destId="{CC3079B4-CEB8-414A-ACEE-D2B104993680}" srcOrd="1" destOrd="0" presId="urn:microsoft.com/office/officeart/2005/8/layout/hierarchy1"/>
+    <dgm:cxn modelId="{1F39BC43-DF4C-471D-94F4-4890EB9D85D0}" type="presParOf" srcId="{1A392811-0146-4262-8761-79D23D35FC2D}" destId="{2B9E0F56-27B1-4331-8049-934533AC2955}" srcOrd="1" destOrd="0" presId="urn:microsoft.com/office/officeart/2005/8/layout/hierarchy1"/>
   </dgm:cxnLst>
   <dgm:bg/>
   <dgm:whole/>
@@ -3829,8 +4175,8 @@
       </dsp:nvSpPr>
       <dsp:spPr>
         <a:xfrm>
-          <a:off x="0" y="430393"/>
-          <a:ext cx="2957512" cy="1878020"/>
+          <a:off x="3080" y="711013"/>
+          <a:ext cx="2199649" cy="1396777"/>
         </a:xfrm>
         <a:prstGeom prst="roundRect">
           <a:avLst>
@@ -3881,8 +4227,8 @@
       </dsp:nvSpPr>
       <dsp:spPr>
         <a:xfrm>
-          <a:off x="328612" y="742575"/>
-          <a:ext cx="2957512" cy="1878020"/>
+          <a:off x="247486" y="943198"/>
+          <a:ext cx="2199649" cy="1396777"/>
         </a:xfrm>
         <a:prstGeom prst="roundRect">
           <a:avLst>
@@ -3925,12 +4271,12 @@
         <a:fontRef idx="minor"/>
       </dsp:style>
       <dsp:txBody>
-        <a:bodyPr spcFirstLastPara="0" vert="horz" wrap="square" lIns="247650" tIns="247650" rIns="247650" bIns="247650" numCol="1" spcCol="1270" anchor="ctr" anchorCtr="0">
+        <a:bodyPr spcFirstLastPara="0" vert="horz" wrap="square" lIns="87630" tIns="87630" rIns="87630" bIns="87630" numCol="1" spcCol="1270" anchor="ctr" anchorCtr="0">
           <a:noAutofit/>
         </a:bodyPr>
         <a:lstStyle/>
         <a:p>
-          <a:pPr marL="0" lvl="0" indent="0" algn="ctr" defTabSz="2889250">
+          <a:pPr marL="0" lvl="0" indent="0" algn="ctr" defTabSz="1022350">
             <a:lnSpc>
               <a:spcPct val="90000"/>
             </a:lnSpc>
@@ -3942,12 +4288,15 @@
             </a:spcAft>
             <a:buNone/>
           </a:pPr>
-          <a:endParaRPr lang="en-US" sz="6500" kern="1200" dirty="0"/>
+          <a:r>
+            <a:rPr lang="en-US" sz="2300" kern="1200" dirty="0"/>
+            <a:t>Fix Email Backend issue</a:t>
+          </a:r>
         </a:p>
       </dsp:txBody>
       <dsp:txXfrm>
-        <a:off x="383617" y="797580"/>
-        <a:ext cx="2847502" cy="1768010"/>
+        <a:off x="288396" y="984108"/>
+        <a:ext cx="2117829" cy="1314957"/>
       </dsp:txXfrm>
     </dsp:sp>
     <dsp:sp modelId="{FE1BC2AB-A6F4-451D-B5E4-EBBE2F580413}">
@@ -3957,8 +4306,8 @@
       </dsp:nvSpPr>
       <dsp:spPr>
         <a:xfrm>
-          <a:off x="3614737" y="430393"/>
-          <a:ext cx="2957512" cy="1878020"/>
+          <a:off x="2691541" y="711013"/>
+          <a:ext cx="2199649" cy="1396777"/>
         </a:xfrm>
         <a:prstGeom prst="roundRect">
           <a:avLst>
@@ -4009,8 +4358,8 @@
       </dsp:nvSpPr>
       <dsp:spPr>
         <a:xfrm>
-          <a:off x="3943350" y="742575"/>
-          <a:ext cx="2957512" cy="1878020"/>
+          <a:off x="2935947" y="943198"/>
+          <a:ext cx="2199649" cy="1396777"/>
         </a:xfrm>
         <a:prstGeom prst="roundRect">
           <a:avLst>
@@ -4053,12 +4402,12 @@
         <a:fontRef idx="minor"/>
       </dsp:style>
       <dsp:txBody>
-        <a:bodyPr spcFirstLastPara="0" vert="horz" wrap="square" lIns="247650" tIns="247650" rIns="247650" bIns="247650" numCol="1" spcCol="1270" anchor="ctr" anchorCtr="0">
+        <a:bodyPr spcFirstLastPara="0" vert="horz" wrap="square" lIns="87630" tIns="87630" rIns="87630" bIns="87630" numCol="1" spcCol="1270" anchor="ctr" anchorCtr="0">
           <a:noAutofit/>
         </a:bodyPr>
         <a:lstStyle/>
         <a:p>
-          <a:pPr marL="0" lvl="0" indent="0" algn="ctr" defTabSz="2889250">
+          <a:pPr marL="0" lvl="0" indent="0" algn="ctr" defTabSz="1022350">
             <a:lnSpc>
               <a:spcPct val="90000"/>
             </a:lnSpc>
@@ -4070,12 +4419,15 @@
             </a:spcAft>
             <a:buNone/>
           </a:pPr>
-          <a:endParaRPr lang="en-US" sz="6500" kern="1200" dirty="0"/>
+          <a:r>
+            <a:rPr lang="en-US" sz="2300" kern="1200" dirty="0"/>
+            <a:t>User Profile Section</a:t>
+          </a:r>
         </a:p>
       </dsp:txBody>
       <dsp:txXfrm>
-        <a:off x="3998355" y="797580"/>
-        <a:ext cx="2847502" cy="1768010"/>
+        <a:off x="2976857" y="984108"/>
+        <a:ext cx="2117829" cy="1314957"/>
       </dsp:txXfrm>
     </dsp:sp>
     <dsp:sp modelId="{CA2C5924-FEEE-41E7-8498-90F97462AB60}">
@@ -4085,8 +4437,8 @@
       </dsp:nvSpPr>
       <dsp:spPr>
         <a:xfrm>
-          <a:off x="7229475" y="430393"/>
-          <a:ext cx="2957512" cy="1878020"/>
+          <a:off x="5380002" y="711013"/>
+          <a:ext cx="2199649" cy="1396777"/>
         </a:xfrm>
         <a:prstGeom prst="roundRect">
           <a:avLst>
@@ -4137,8 +4489,8 @@
       </dsp:nvSpPr>
       <dsp:spPr>
         <a:xfrm>
-          <a:off x="7558087" y="742575"/>
-          <a:ext cx="2957512" cy="1878020"/>
+          <a:off x="5624408" y="943198"/>
+          <a:ext cx="2199649" cy="1396777"/>
         </a:xfrm>
         <a:prstGeom prst="roundRect">
           <a:avLst>
@@ -4181,12 +4533,12 @@
         <a:fontRef idx="minor"/>
       </dsp:style>
       <dsp:txBody>
-        <a:bodyPr spcFirstLastPara="0" vert="horz" wrap="square" lIns="247650" tIns="247650" rIns="247650" bIns="247650" numCol="1" spcCol="1270" anchor="ctr" anchorCtr="0">
+        <a:bodyPr spcFirstLastPara="0" vert="horz" wrap="square" lIns="87630" tIns="87630" rIns="87630" bIns="87630" numCol="1" spcCol="1270" anchor="ctr" anchorCtr="0">
           <a:noAutofit/>
         </a:bodyPr>
         <a:lstStyle/>
         <a:p>
-          <a:pPr marL="0" lvl="0" indent="0" algn="ctr" defTabSz="2889250">
+          <a:pPr marL="0" lvl="0" indent="0" algn="ctr" defTabSz="1022350">
             <a:lnSpc>
               <a:spcPct val="90000"/>
             </a:lnSpc>
@@ -4198,12 +4550,147 @@
             </a:spcAft>
             <a:buNone/>
           </a:pPr>
-          <a:endParaRPr lang="en-US" sz="6500" kern="1200" dirty="0"/>
+          <a:r>
+            <a:rPr lang="en-US" sz="2300" kern="1200" dirty="0"/>
+            <a:t>Continue development on other pages</a:t>
+          </a:r>
         </a:p>
       </dsp:txBody>
       <dsp:txXfrm>
-        <a:off x="7613092" y="797580"/>
-        <a:ext cx="2847502" cy="1768010"/>
+        <a:off x="5665318" y="984108"/>
+        <a:ext cx="2117829" cy="1314957"/>
+      </dsp:txXfrm>
+    </dsp:sp>
+    <dsp:sp modelId="{45E38DED-5226-4ACC-AAA7-64518879BBE1}">
+      <dsp:nvSpPr>
+        <dsp:cNvPr id="0" name=""/>
+        <dsp:cNvSpPr/>
+      </dsp:nvSpPr>
+      <dsp:spPr>
+        <a:xfrm>
+          <a:off x="8068463" y="711013"/>
+          <a:ext cx="2199649" cy="1396777"/>
+        </a:xfrm>
+        <a:prstGeom prst="roundRect">
+          <a:avLst>
+            <a:gd name="adj" fmla="val 10000"/>
+          </a:avLst>
+        </a:prstGeom>
+        <a:solidFill>
+          <a:schemeClr val="accent2">
+            <a:hueOff val="0"/>
+            <a:satOff val="0"/>
+            <a:lumOff val="0"/>
+            <a:alphaOff val="0"/>
+          </a:schemeClr>
+        </a:solidFill>
+        <a:ln w="19050" cap="flat" cmpd="sng" algn="ctr">
+          <a:solidFill>
+            <a:schemeClr val="lt1">
+              <a:hueOff val="0"/>
+              <a:satOff val="0"/>
+              <a:lumOff val="0"/>
+              <a:alphaOff val="0"/>
+            </a:schemeClr>
+          </a:solidFill>
+          <a:prstDash val="solid"/>
+          <a:miter lim="800000"/>
+        </a:ln>
+        <a:effectLst/>
+      </dsp:spPr>
+      <dsp:style>
+        <a:lnRef idx="2">
+          <a:scrgbClr r="0" g="0" b="0"/>
+        </a:lnRef>
+        <a:fillRef idx="1">
+          <a:scrgbClr r="0" g="0" b="0"/>
+        </a:fillRef>
+        <a:effectRef idx="0">
+          <a:scrgbClr r="0" g="0" b="0"/>
+        </a:effectRef>
+        <a:fontRef idx="minor">
+          <a:schemeClr val="lt1"/>
+        </a:fontRef>
+      </dsp:style>
+    </dsp:sp>
+    <dsp:sp modelId="{CC3079B4-CEB8-414A-ACEE-D2B104993680}">
+      <dsp:nvSpPr>
+        <dsp:cNvPr id="0" name=""/>
+        <dsp:cNvSpPr/>
+      </dsp:nvSpPr>
+      <dsp:spPr>
+        <a:xfrm>
+          <a:off x="8312869" y="943198"/>
+          <a:ext cx="2199649" cy="1396777"/>
+        </a:xfrm>
+        <a:prstGeom prst="roundRect">
+          <a:avLst>
+            <a:gd name="adj" fmla="val 10000"/>
+          </a:avLst>
+        </a:prstGeom>
+        <a:solidFill>
+          <a:schemeClr val="lt1">
+            <a:alpha val="90000"/>
+            <a:hueOff val="0"/>
+            <a:satOff val="0"/>
+            <a:lumOff val="0"/>
+            <a:alphaOff val="0"/>
+          </a:schemeClr>
+        </a:solidFill>
+        <a:ln w="19050" cap="flat" cmpd="sng" algn="ctr">
+          <a:solidFill>
+            <a:schemeClr val="accent2">
+              <a:hueOff val="0"/>
+              <a:satOff val="0"/>
+              <a:lumOff val="0"/>
+              <a:alphaOff val="0"/>
+            </a:schemeClr>
+          </a:solidFill>
+          <a:prstDash val="solid"/>
+          <a:miter lim="800000"/>
+        </a:ln>
+        <a:effectLst/>
+      </dsp:spPr>
+      <dsp:style>
+        <a:lnRef idx="2">
+          <a:scrgbClr r="0" g="0" b="0"/>
+        </a:lnRef>
+        <a:fillRef idx="1">
+          <a:scrgbClr r="0" g="0" b="0"/>
+        </a:fillRef>
+        <a:effectRef idx="0">
+          <a:scrgbClr r="0" g="0" b="0"/>
+        </a:effectRef>
+        <a:fontRef idx="minor"/>
+      </dsp:style>
+      <dsp:txBody>
+        <a:bodyPr spcFirstLastPara="0" vert="horz" wrap="square" lIns="87630" tIns="87630" rIns="87630" bIns="87630" numCol="1" spcCol="1270" anchor="ctr" anchorCtr="0">
+          <a:noAutofit/>
+        </a:bodyPr>
+        <a:lstStyle/>
+        <a:p>
+          <a:pPr marL="0" lvl="0" indent="0" algn="ctr" defTabSz="1022350">
+            <a:lnSpc>
+              <a:spcPct val="90000"/>
+            </a:lnSpc>
+            <a:spcBef>
+              <a:spcPct val="0"/>
+            </a:spcBef>
+            <a:spcAft>
+              <a:spcPct val="35000"/>
+            </a:spcAft>
+            <a:buNone/>
+          </a:pPr>
+          <a:r>
+            <a:rPr lang="en-US" sz="2300" kern="1200"/>
+            <a:t>Maps Page</a:t>
+          </a:r>
+          <a:endParaRPr lang="en-US" sz="2300" kern="1200" dirty="0"/>
+        </a:p>
+      </dsp:txBody>
+      <dsp:txXfrm>
+        <a:off x="8353779" y="984108"/>
+        <a:ext cx="2117829" cy="1314957"/>
       </dsp:txXfrm>
     </dsp:sp>
   </dsp:spTree>
@@ -10928,6 +11415,749 @@
     </p:bg>
     <p:spTree>
       <p:nvGrpSpPr>
+        <p:cNvPr id="1" name="">
+          <a:extLst>
+            <a:ext uri="{FF2B5EF4-FFF2-40B4-BE49-F238E27FC236}">
+              <a16:creationId xmlns:a16="http://schemas.microsoft.com/office/drawing/2014/main" id="{38138CFD-A501-8AEC-C666-BED845111F6D}"/>
+            </a:ext>
+          </a:extLst>
+        </p:cNvPr>
+        <p:cNvGrpSpPr/>
+        <p:nvPr/>
+      </p:nvGrpSpPr>
+      <p:grpSpPr>
+        <a:xfrm>
+          <a:off x="0" y="0"/>
+          <a:ext cx="0" cy="0"/>
+          <a:chOff x="0" y="0"/>
+          <a:chExt cx="0" cy="0"/>
+        </a:xfrm>
+      </p:grpSpPr>
+      <p:sp useBgFill="1">
+        <p:nvSpPr>
+          <p:cNvPr id="21" name="Rectangle 20">
+            <a:extLst>
+              <a:ext uri="{FF2B5EF4-FFF2-40B4-BE49-F238E27FC236}">
+                <a16:creationId xmlns:a16="http://schemas.microsoft.com/office/drawing/2014/main" id="{356F68EF-088F-20DD-B4B1-6BCF0A8C9BF2}"/>
+              </a:ext>
+              <a:ext uri="{C183D7F6-B498-43B3-948B-1728B52AA6E4}">
+                <adec:decorative xmlns:adec="http://schemas.microsoft.com/office/drawing/2017/decorative" val="1"/>
+              </a:ext>
+            </a:extLst>
+          </p:cNvPr>
+          <p:cNvSpPr>
+            <a:spLocks noGrp="1" noRot="1" noChangeAspect="1" noMove="1" noResize="1" noEditPoints="1" noAdjustHandles="1" noChangeArrowheads="1" noChangeShapeType="1" noTextEdit="1"/>
+          </p:cNvSpPr>
+          <p:nvPr>
+            <p:extLst>
+              <p:ext uri="{386F3935-93C4-4BCD-93E2-E3B085C9AB24}">
+                <p16:designElem xmlns:p16="http://schemas.microsoft.com/office/powerpoint/2015/main" val="1"/>
+              </p:ext>
+            </p:extLst>
+          </p:nvPr>
+        </p:nvSpPr>
+        <p:spPr>
+          <a:xfrm>
+            <a:off x="0" y="0"/>
+            <a:ext cx="12191999" cy="6857365"/>
+          </a:xfrm>
+          <a:prstGeom prst="rect">
+            <a:avLst/>
+          </a:prstGeom>
+          <a:ln>
+            <a:noFill/>
+          </a:ln>
+        </p:spPr>
+        <p:style>
+          <a:lnRef idx="2">
+            <a:schemeClr val="accent1">
+              <a:shade val="50000"/>
+            </a:schemeClr>
+          </a:lnRef>
+          <a:fillRef idx="1">
+            <a:schemeClr val="accent1"/>
+          </a:fillRef>
+          <a:effectRef idx="0">
+            <a:schemeClr val="accent1"/>
+          </a:effectRef>
+          <a:fontRef idx="minor">
+            <a:schemeClr val="lt1"/>
+          </a:fontRef>
+        </p:style>
+        <p:txBody>
+          <a:bodyPr rtlCol="0" anchor="ctr"/>
+          <a:lstStyle/>
+          <a:p>
+            <a:pPr algn="ctr"/>
+            <a:endParaRPr lang="en-US"/>
+          </a:p>
+        </p:txBody>
+      </p:sp>
+      <p:sp>
+        <p:nvSpPr>
+          <p:cNvPr id="22" name="Rectangle 21">
+            <a:extLst>
+              <a:ext uri="{FF2B5EF4-FFF2-40B4-BE49-F238E27FC236}">
+                <a16:creationId xmlns:a16="http://schemas.microsoft.com/office/drawing/2014/main" id="{9EF082FE-D96F-0D2A-34AA-F987D0796D34}"/>
+              </a:ext>
+              <a:ext uri="{C183D7F6-B498-43B3-948B-1728B52AA6E4}">
+                <adec:decorative xmlns:adec="http://schemas.microsoft.com/office/drawing/2017/decorative" val="1"/>
+              </a:ext>
+            </a:extLst>
+          </p:cNvPr>
+          <p:cNvSpPr>
+            <a:spLocks noGrp="1" noRot="1" noChangeAspect="1" noMove="1" noResize="1" noEditPoints="1" noAdjustHandles="1" noChangeArrowheads="1" noChangeShapeType="1" noTextEdit="1"/>
+          </p:cNvSpPr>
+          <p:nvPr>
+            <p:extLst>
+              <p:ext uri="{386F3935-93C4-4BCD-93E2-E3B085C9AB24}">
+                <p16:designElem xmlns:p16="http://schemas.microsoft.com/office/powerpoint/2015/main" val="1"/>
+              </p:ext>
+            </p:extLst>
+          </p:nvPr>
+        </p:nvSpPr>
+        <p:spPr>
+          <a:xfrm>
+            <a:off x="0" y="1"/>
+            <a:ext cx="12192000" cy="5187142"/>
+          </a:xfrm>
+          <a:prstGeom prst="rect">
+            <a:avLst/>
+          </a:prstGeom>
+          <a:solidFill>
+            <a:schemeClr val="accent4"/>
+          </a:solidFill>
+          <a:ln>
+            <a:noFill/>
+          </a:ln>
+        </p:spPr>
+        <p:style>
+          <a:lnRef idx="2">
+            <a:schemeClr val="accent1">
+              <a:shade val="50000"/>
+            </a:schemeClr>
+          </a:lnRef>
+          <a:fillRef idx="1">
+            <a:schemeClr val="accent1"/>
+          </a:fillRef>
+          <a:effectRef idx="0">
+            <a:schemeClr val="accent1"/>
+          </a:effectRef>
+          <a:fontRef idx="minor">
+            <a:schemeClr val="lt1"/>
+          </a:fontRef>
+        </p:style>
+        <p:txBody>
+          <a:bodyPr rtlCol="0" anchor="ctr"/>
+          <a:lstStyle/>
+          <a:p>
+            <a:pPr algn="ctr"/>
+            <a:endParaRPr lang="en-US" dirty="0"/>
+          </a:p>
+        </p:txBody>
+      </p:sp>
+      <p:sp>
+        <p:nvSpPr>
+          <p:cNvPr id="23" name="Rectangle 22">
+            <a:extLst>
+              <a:ext uri="{FF2B5EF4-FFF2-40B4-BE49-F238E27FC236}">
+                <a16:creationId xmlns:a16="http://schemas.microsoft.com/office/drawing/2014/main" id="{0BE13FF0-F6F1-375E-D271-70DAE72E1AC7}"/>
+              </a:ext>
+              <a:ext uri="{C183D7F6-B498-43B3-948B-1728B52AA6E4}">
+                <adec:decorative xmlns:adec="http://schemas.microsoft.com/office/drawing/2017/decorative" val="1"/>
+              </a:ext>
+            </a:extLst>
+          </p:cNvPr>
+          <p:cNvSpPr>
+            <a:spLocks noGrp="1" noRot="1" noChangeAspect="1" noMove="1" noResize="1" noEditPoints="1" noAdjustHandles="1" noChangeArrowheads="1" noChangeShapeType="1" noTextEdit="1"/>
+          </p:cNvSpPr>
+          <p:nvPr>
+            <p:extLst>
+              <p:ext uri="{386F3935-93C4-4BCD-93E2-E3B085C9AB24}">
+                <p16:designElem xmlns:p16="http://schemas.microsoft.com/office/powerpoint/2015/main" val="1"/>
+              </p:ext>
+            </p:extLst>
+          </p:nvPr>
+        </p:nvSpPr>
+        <p:spPr>
+          <a:xfrm>
+            <a:off x="596464" y="551961"/>
+            <a:ext cx="10999072" cy="5399950"/>
+          </a:xfrm>
+          <a:prstGeom prst="rect">
+            <a:avLst/>
+          </a:prstGeom>
+          <a:solidFill>
+            <a:schemeClr val="bg1"/>
+          </a:solidFill>
+          <a:ln>
+            <a:noFill/>
+          </a:ln>
+          <a:effectLst>
+            <a:outerShdw blurRad="139700" dist="127000" dir="5400000" algn="t" rotWithShape="0">
+              <a:prstClr val="black">
+                <a:alpha val="15000"/>
+              </a:prstClr>
+            </a:outerShdw>
+          </a:effectLst>
+        </p:spPr>
+        <p:style>
+          <a:lnRef idx="2">
+            <a:schemeClr val="accent1">
+              <a:shade val="50000"/>
+            </a:schemeClr>
+          </a:lnRef>
+          <a:fillRef idx="1">
+            <a:schemeClr val="accent1"/>
+          </a:fillRef>
+          <a:effectRef idx="0">
+            <a:schemeClr val="accent1"/>
+          </a:effectRef>
+          <a:fontRef idx="minor">
+            <a:schemeClr val="lt1"/>
+          </a:fontRef>
+        </p:style>
+        <p:txBody>
+          <a:bodyPr rtlCol="0" anchor="ctr"/>
+          <a:lstStyle/>
+          <a:p>
+            <a:pPr algn="ctr"/>
+            <a:endParaRPr lang="en-US"/>
+          </a:p>
+        </p:txBody>
+      </p:sp>
+      <p:cxnSp>
+        <p:nvCxnSpPr>
+          <p:cNvPr id="25" name="Straight Connector 24">
+            <a:extLst>
+              <a:ext uri="{FF2B5EF4-FFF2-40B4-BE49-F238E27FC236}">
+                <a16:creationId xmlns:a16="http://schemas.microsoft.com/office/drawing/2014/main" id="{3A7F67B2-22A5-7F2D-13EB-E06229F5CB46}"/>
+              </a:ext>
+              <a:ext uri="{C183D7F6-B498-43B3-948B-1728B52AA6E4}">
+                <adec:decorative xmlns:adec="http://schemas.microsoft.com/office/drawing/2017/decorative" val="1"/>
+              </a:ext>
+            </a:extLst>
+          </p:cNvPr>
+          <p:cNvCxnSpPr>
+            <a:cxnSpLocks noGrp="1" noRot="1" noChangeAspect="1" noMove="1" noResize="1" noEditPoints="1" noAdjustHandles="1" noChangeArrowheads="1" noChangeShapeType="1"/>
+          </p:cNvCxnSpPr>
+          <p:nvPr>
+            <p:extLst>
+              <p:ext uri="{386F3935-93C4-4BCD-93E2-E3B085C9AB24}">
+                <p16:designElem xmlns:p16="http://schemas.microsoft.com/office/powerpoint/2015/main" val="1"/>
+              </p:ext>
+            </p:extLst>
+          </p:nvPr>
+        </p:nvCxnSpPr>
+        <p:spPr>
+          <a:xfrm flipH="1">
+            <a:off x="596464" y="6329769"/>
+            <a:ext cx="11000232" cy="0"/>
+          </a:xfrm>
+          <a:prstGeom prst="line">
+            <a:avLst/>
+          </a:prstGeom>
+          <a:ln w="152400">
+            <a:solidFill>
+              <a:schemeClr val="accent4"/>
+            </a:solidFill>
+          </a:ln>
+        </p:spPr>
+        <p:style>
+          <a:lnRef idx="1">
+            <a:schemeClr val="accent1"/>
+          </a:lnRef>
+          <a:fillRef idx="0">
+            <a:schemeClr val="accent1"/>
+          </a:fillRef>
+          <a:effectRef idx="0">
+            <a:schemeClr val="accent1"/>
+          </a:effectRef>
+          <a:fontRef idx="minor">
+            <a:schemeClr val="tx1"/>
+          </a:fontRef>
+        </p:style>
+      </p:cxnSp>
+      <p:sp>
+        <p:nvSpPr>
+          <p:cNvPr id="9" name="Title 1">
+            <a:extLst>
+              <a:ext uri="{FF2B5EF4-FFF2-40B4-BE49-F238E27FC236}">
+                <a16:creationId xmlns:a16="http://schemas.microsoft.com/office/drawing/2014/main" id="{D6D36DC8-D9BF-8C26-69EA-ED89E34DB644}"/>
+              </a:ext>
+            </a:extLst>
+          </p:cNvPr>
+          <p:cNvSpPr>
+            <a:spLocks noGrp="1"/>
+          </p:cNvSpPr>
+          <p:nvPr>
+            <p:ph type="title"/>
+          </p:nvPr>
+        </p:nvSpPr>
+        <p:spPr>
+          <a:xfrm>
+            <a:off x="4008559" y="768350"/>
+            <a:ext cx="4162181" cy="920920"/>
+          </a:xfrm>
+        </p:spPr>
+        <p:txBody>
+          <a:bodyPr/>
+          <a:lstStyle/>
+          <a:p>
+            <a:r>
+              <a:rPr lang="en-US"/>
+              <a:t>Week 8 </a:t>
+            </a:r>
+            <a:r>
+              <a:rPr lang="en-US" dirty="0"/>
+              <a:t>Plan</a:t>
+            </a:r>
+          </a:p>
+        </p:txBody>
+      </p:sp>
+      <p:graphicFrame>
+        <p:nvGraphicFramePr>
+          <p:cNvPr id="27" name="Text Placeholder 2">
+            <a:extLst>
+              <a:ext uri="{FF2B5EF4-FFF2-40B4-BE49-F238E27FC236}">
+                <a16:creationId xmlns:a16="http://schemas.microsoft.com/office/drawing/2014/main" id="{D6B93F0B-FEB0-EDAB-CFE1-A57DEFE97FCD}"/>
+              </a:ext>
+            </a:extLst>
+          </p:cNvPr>
+          <p:cNvGraphicFramePr/>
+          <p:nvPr>
+            <p:extLst>
+              <p:ext uri="{D42A27DB-BD31-4B8C-83A1-F6EECF244321}">
+                <p14:modId xmlns:p14="http://schemas.microsoft.com/office/powerpoint/2010/main" val="1312966704"/>
+              </p:ext>
+            </p:extLst>
+          </p:nvPr>
+        </p:nvGraphicFramePr>
+        <p:xfrm>
+          <a:off x="838199" y="2688113"/>
+          <a:ext cx="10515600" cy="3050990"/>
+        </p:xfrm>
+        <a:graphic>
+          <a:graphicData uri="http://schemas.openxmlformats.org/drawingml/2006/diagram">
+            <dgm:relIds xmlns:dgm="http://schemas.openxmlformats.org/drawingml/2006/diagram" xmlns:r="http://schemas.openxmlformats.org/officeDocument/2006/relationships" r:dm="rId2" r:lo="rId3" r:qs="rId4" r:cs="rId5"/>
+          </a:graphicData>
+        </a:graphic>
+      </p:graphicFrame>
+    </p:spTree>
+    <p:extLst>
+      <p:ext uri="{BB962C8B-B14F-4D97-AF65-F5344CB8AC3E}">
+        <p14:creationId xmlns:p14="http://schemas.microsoft.com/office/powerpoint/2010/main" val="2561402868"/>
+      </p:ext>
+    </p:extLst>
+  </p:cSld>
+  <p:clrMapOvr>
+    <a:masterClrMapping/>
+  </p:clrMapOvr>
+</p:sld>
+</file>
+
+<file path=ppt/slides/slide11.xml><?xml version="1.0" encoding="utf-8"?>
+<p:sld xmlns:a="http://schemas.openxmlformats.org/drawingml/2006/main" xmlns:r="http://schemas.openxmlformats.org/officeDocument/2006/relationships" xmlns:p="http://schemas.openxmlformats.org/presentationml/2006/main">
+  <p:cSld>
+    <p:bg>
+      <p:bgPr>
+        <a:solidFill>
+          <a:schemeClr val="bg1"/>
+        </a:solidFill>
+        <a:effectLst/>
+      </p:bgPr>
+    </p:bg>
+    <p:spTree>
+      <p:nvGrpSpPr>
+        <p:cNvPr id="1" name=""/>
+        <p:cNvGrpSpPr/>
+        <p:nvPr/>
+      </p:nvGrpSpPr>
+      <p:grpSpPr>
+        <a:xfrm>
+          <a:off x="0" y="0"/>
+          <a:ext cx="0" cy="0"/>
+          <a:chOff x="0" y="0"/>
+          <a:chExt cx="0" cy="0"/>
+        </a:xfrm>
+      </p:grpSpPr>
+      <p:sp useBgFill="1">
+        <p:nvSpPr>
+          <p:cNvPr id="28" name="Rectangle 27">
+            <a:extLst>
+              <a:ext uri="{FF2B5EF4-FFF2-40B4-BE49-F238E27FC236}">
+                <a16:creationId xmlns:a16="http://schemas.microsoft.com/office/drawing/2014/main" id="{C1A1C5D3-C053-4EE9-BE1A-419B6E27CCAE}"/>
+              </a:ext>
+              <a:ext uri="{C183D7F6-B498-43B3-948B-1728B52AA6E4}">
+                <adec:decorative xmlns:adec="http://schemas.microsoft.com/office/drawing/2017/decorative" val="1"/>
+              </a:ext>
+            </a:extLst>
+          </p:cNvPr>
+          <p:cNvSpPr>
+            <a:spLocks noGrp="1" noRot="1" noChangeAspect="1" noMove="1" noResize="1" noEditPoints="1" noAdjustHandles="1" noChangeArrowheads="1" noChangeShapeType="1" noTextEdit="1"/>
+          </p:cNvSpPr>
+          <p:nvPr>
+            <p:extLst>
+              <p:ext uri="{386F3935-93C4-4BCD-93E2-E3B085C9AB24}">
+                <p16:designElem xmlns:p16="http://schemas.microsoft.com/office/powerpoint/2015/main" val="1"/>
+              </p:ext>
+            </p:extLst>
+          </p:nvPr>
+        </p:nvSpPr>
+        <p:spPr>
+          <a:xfrm>
+            <a:off x="0" y="0"/>
+            <a:ext cx="12192000" cy="6858000"/>
+          </a:xfrm>
+          <a:prstGeom prst="rect">
+            <a:avLst/>
+          </a:prstGeom>
+          <a:ln>
+            <a:noFill/>
+          </a:ln>
+        </p:spPr>
+        <p:style>
+          <a:lnRef idx="2">
+            <a:schemeClr val="accent1">
+              <a:shade val="50000"/>
+            </a:schemeClr>
+          </a:lnRef>
+          <a:fillRef idx="1">
+            <a:schemeClr val="accent1"/>
+          </a:fillRef>
+          <a:effectRef idx="0">
+            <a:schemeClr val="accent1"/>
+          </a:effectRef>
+          <a:fontRef idx="minor">
+            <a:schemeClr val="lt1"/>
+          </a:fontRef>
+        </p:style>
+        <p:txBody>
+          <a:bodyPr rtlCol="0" anchor="ctr"/>
+          <a:lstStyle/>
+          <a:p>
+            <a:pPr algn="ctr"/>
+            <a:endParaRPr lang="en-US"/>
+          </a:p>
+        </p:txBody>
+      </p:sp>
+      <p:sp useBgFill="1">
+        <p:nvSpPr>
+          <p:cNvPr id="30" name="Rectangle 29">
+            <a:extLst>
+              <a:ext uri="{FF2B5EF4-FFF2-40B4-BE49-F238E27FC236}">
+                <a16:creationId xmlns:a16="http://schemas.microsoft.com/office/drawing/2014/main" id="{A3473CF9-37EB-43E7-89EF-D2D1C53D1DAC}"/>
+              </a:ext>
+              <a:ext uri="{C183D7F6-B498-43B3-948B-1728B52AA6E4}">
+                <adec:decorative xmlns:adec="http://schemas.microsoft.com/office/drawing/2017/decorative" val="1"/>
+              </a:ext>
+            </a:extLst>
+          </p:cNvPr>
+          <p:cNvSpPr>
+            <a:spLocks noGrp="1" noRot="1" noChangeAspect="1" noMove="1" noResize="1" noEditPoints="1" noAdjustHandles="1" noChangeArrowheads="1" noChangeShapeType="1" noTextEdit="1"/>
+          </p:cNvSpPr>
+          <p:nvPr>
+            <p:extLst>
+              <p:ext uri="{386F3935-93C4-4BCD-93E2-E3B085C9AB24}">
+                <p16:designElem xmlns:p16="http://schemas.microsoft.com/office/powerpoint/2015/main" val="1"/>
+              </p:ext>
+            </p:extLst>
+          </p:nvPr>
+        </p:nvSpPr>
+        <p:spPr>
+          <a:xfrm>
+            <a:off x="1903615" y="221673"/>
+            <a:ext cx="8384770" cy="1332634"/>
+          </a:xfrm>
+          <a:prstGeom prst="rect">
+            <a:avLst/>
+          </a:prstGeom>
+          <a:ln w="12700">
+            <a:solidFill>
+              <a:srgbClr val="E1E1E1"/>
+            </a:solidFill>
+          </a:ln>
+          <a:effectLst>
+            <a:outerShdw blurRad="50800" dist="38100" dir="2700000" algn="tl" rotWithShape="0">
+              <a:schemeClr val="bg2">
+                <a:lumMod val="85000"/>
+                <a:alpha val="50000"/>
+              </a:schemeClr>
+            </a:outerShdw>
+          </a:effectLst>
+        </p:spPr>
+        <p:style>
+          <a:lnRef idx="2">
+            <a:schemeClr val="accent1">
+              <a:shade val="50000"/>
+            </a:schemeClr>
+          </a:lnRef>
+          <a:fillRef idx="1">
+            <a:schemeClr val="accent1"/>
+          </a:fillRef>
+          <a:effectRef idx="0">
+            <a:schemeClr val="accent1"/>
+          </a:effectRef>
+          <a:fontRef idx="minor">
+            <a:schemeClr val="lt1"/>
+          </a:fontRef>
+        </p:style>
+        <p:txBody>
+          <a:bodyPr rtlCol="0" anchor="ctr"/>
+          <a:lstStyle/>
+          <a:p>
+            <a:pPr marL="0" marR="0" lvl="0" indent="0" algn="ctr" defTabSz="914400" rtl="0" eaLnBrk="1" fontAlgn="auto" latinLnBrk="0" hangingPunct="1">
+              <a:lnSpc>
+                <a:spcPct val="100000"/>
+              </a:lnSpc>
+              <a:spcBef>
+                <a:spcPts val="0"/>
+              </a:spcBef>
+              <a:spcAft>
+                <a:spcPts val="0"/>
+              </a:spcAft>
+              <a:buClrTx/>
+              <a:buSzTx/>
+              <a:buFontTx/>
+              <a:buNone/>
+              <a:tabLst/>
+              <a:defRPr/>
+            </a:pPr>
+            <a:endParaRPr kumimoji="0" lang="en-US" sz="1800" b="0" i="0" u="none" strike="noStrike" kern="1200" cap="none" spc="0" normalizeH="0" baseline="0" noProof="0">
+              <a:ln>
+                <a:noFill/>
+              </a:ln>
+              <a:solidFill>
+                <a:prstClr val="white"/>
+              </a:solidFill>
+              <a:effectLst/>
+              <a:uLnTx/>
+              <a:uFillTx/>
+              <a:latin typeface="Calibri" panose="020F0502020204030204"/>
+              <a:ea typeface="+mn-ea"/>
+              <a:cs typeface="+mn-cs"/>
+            </a:endParaRPr>
+          </a:p>
+        </p:txBody>
+      </p:sp>
+      <p:sp>
+        <p:nvSpPr>
+          <p:cNvPr id="2" name="Title 1">
+            <a:extLst>
+              <a:ext uri="{FF2B5EF4-FFF2-40B4-BE49-F238E27FC236}">
+                <a16:creationId xmlns:a16="http://schemas.microsoft.com/office/drawing/2014/main" id="{7523CF74-09B7-84B3-F859-D7073DC1C80F}"/>
+              </a:ext>
+            </a:extLst>
+          </p:cNvPr>
+          <p:cNvSpPr>
+            <a:spLocks noGrp="1"/>
+          </p:cNvSpPr>
+          <p:nvPr>
+            <p:ph type="title"/>
+          </p:nvPr>
+        </p:nvSpPr>
+        <p:spPr>
+          <a:xfrm>
+            <a:off x="2103121" y="310343"/>
+            <a:ext cx="7985759" cy="868823"/>
+          </a:xfrm>
+        </p:spPr>
+        <p:txBody>
+          <a:bodyPr vert="horz" lIns="91440" tIns="45720" rIns="91440" bIns="45720" rtlCol="0" anchor="ctr">
+            <a:normAutofit/>
+          </a:bodyPr>
+          <a:lstStyle/>
+          <a:p>
+            <a:pPr algn="ctr"/>
+            <a:r>
+              <a:rPr lang="en-US" sz="4000" kern="1200">
+                <a:solidFill>
+                  <a:schemeClr val="tx1"/>
+                </a:solidFill>
+                <a:latin typeface="+mj-lt"/>
+                <a:ea typeface="+mj-ea"/>
+                <a:cs typeface="+mj-cs"/>
+              </a:rPr>
+              <a:t>Planning</a:t>
+            </a:r>
+          </a:p>
+        </p:txBody>
+      </p:sp>
+      <p:sp>
+        <p:nvSpPr>
+          <p:cNvPr id="32" name="Rectangle: Rounded Corners 31">
+            <a:extLst>
+              <a:ext uri="{FF2B5EF4-FFF2-40B4-BE49-F238E27FC236}">
+                <a16:creationId xmlns:a16="http://schemas.microsoft.com/office/drawing/2014/main" id="{586B4EF9-43BA-4655-A6FF-1D8E21574C95}"/>
+              </a:ext>
+              <a:ext uri="{C183D7F6-B498-43B3-948B-1728B52AA6E4}">
+                <adec:decorative xmlns:adec="http://schemas.microsoft.com/office/drawing/2017/decorative" val="1"/>
+              </a:ext>
+            </a:extLst>
+          </p:cNvPr>
+          <p:cNvSpPr>
+            <a:spLocks noGrp="1" noRot="1" noChangeAspect="1" noMove="1" noResize="1" noEditPoints="1" noAdjustHandles="1" noChangeArrowheads="1" noChangeShapeType="1" noTextEdit="1"/>
+          </p:cNvSpPr>
+          <p:nvPr>
+            <p:extLst>
+              <p:ext uri="{386F3935-93C4-4BCD-93E2-E3B085C9AB24}">
+                <p16:designElem xmlns:p16="http://schemas.microsoft.com/office/powerpoint/2015/main" val="1"/>
+              </p:ext>
+            </p:extLst>
+          </p:nvPr>
+        </p:nvSpPr>
+        <p:spPr>
+          <a:xfrm>
+            <a:off x="2483110" y="1211407"/>
+            <a:ext cx="7225780" cy="685800"/>
+          </a:xfrm>
+          <a:prstGeom prst="roundRect">
+            <a:avLst>
+              <a:gd name="adj" fmla="val 0"/>
+            </a:avLst>
+          </a:prstGeom>
+          <a:solidFill>
+            <a:schemeClr val="accent2"/>
+          </a:solidFill>
+          <a:ln>
+            <a:noFill/>
+          </a:ln>
+        </p:spPr>
+        <p:style>
+          <a:lnRef idx="2">
+            <a:schemeClr val="accent1">
+              <a:shade val="50000"/>
+            </a:schemeClr>
+          </a:lnRef>
+          <a:fillRef idx="1">
+            <a:schemeClr val="accent1"/>
+          </a:fillRef>
+          <a:effectRef idx="0">
+            <a:schemeClr val="accent1"/>
+          </a:effectRef>
+          <a:fontRef idx="minor">
+            <a:schemeClr val="lt1"/>
+          </a:fontRef>
+        </p:style>
+        <p:txBody>
+          <a:bodyPr rtlCol="0" anchor="ctr"/>
+          <a:lstStyle/>
+          <a:p>
+            <a:pPr algn="ctr"/>
+            <a:endParaRPr lang="en-US">
+              <a:solidFill>
+                <a:prstClr val="white"/>
+              </a:solidFill>
+              <a:latin typeface="Calibri" panose="020F0502020204030204"/>
+            </a:endParaRPr>
+          </a:p>
+        </p:txBody>
+      </p:sp>
+      <p:sp>
+        <p:nvSpPr>
+          <p:cNvPr id="3" name="Text Placeholder 2">
+            <a:extLst>
+              <a:ext uri="{FF2B5EF4-FFF2-40B4-BE49-F238E27FC236}">
+                <a16:creationId xmlns:a16="http://schemas.microsoft.com/office/drawing/2014/main" id="{C605E30C-3490-D1E3-740D-40AD5E393958}"/>
+              </a:ext>
+            </a:extLst>
+          </p:cNvPr>
+          <p:cNvSpPr>
+            <a:spLocks noGrp="1"/>
+          </p:cNvSpPr>
+          <p:nvPr>
+            <p:ph type="body" idx="1"/>
+          </p:nvPr>
+        </p:nvSpPr>
+        <p:spPr>
+          <a:xfrm>
+            <a:off x="2615738" y="1263807"/>
+            <a:ext cx="6960524" cy="598516"/>
+          </a:xfrm>
+        </p:spPr>
+        <p:txBody>
+          <a:bodyPr vert="horz" lIns="91440" tIns="45720" rIns="91440" bIns="45720" rtlCol="0" anchor="ctr">
+            <a:normAutofit/>
+          </a:bodyPr>
+          <a:lstStyle/>
+          <a:p>
+            <a:pPr algn="ctr"/>
+            <a:r>
+              <a:rPr lang="en-US" sz="2000" kern="1200">
+                <a:solidFill>
+                  <a:schemeClr val="bg1"/>
+                </a:solidFill>
+                <a:latin typeface="+mn-lt"/>
+                <a:ea typeface="+mn-ea"/>
+                <a:cs typeface="+mn-cs"/>
+              </a:rPr>
+              <a:t>Gant chart</a:t>
+            </a:r>
+          </a:p>
+        </p:txBody>
+      </p:sp>
+      <p:pic>
+        <p:nvPicPr>
+          <p:cNvPr id="5" name="Picture 4">
+            <a:extLst>
+              <a:ext uri="{FF2B5EF4-FFF2-40B4-BE49-F238E27FC236}">
+                <a16:creationId xmlns:a16="http://schemas.microsoft.com/office/drawing/2014/main" id="{30D9BB01-16EE-371C-49E8-833A93D92451}"/>
+              </a:ext>
+            </a:extLst>
+          </p:cNvPr>
+          <p:cNvPicPr>
+            <a:picLocks noChangeAspect="1"/>
+          </p:cNvPicPr>
+          <p:nvPr/>
+        </p:nvPicPr>
+        <p:blipFill>
+          <a:blip r:embed="rId2"/>
+          <a:srcRect r="3514"/>
+          <a:stretch>
+            <a:fillRect/>
+          </a:stretch>
+        </p:blipFill>
+        <p:spPr>
+          <a:xfrm>
+            <a:off x="0" y="2219602"/>
+            <a:ext cx="12191999" cy="4608716"/>
+          </a:xfrm>
+          <a:prstGeom prst="rect">
+            <a:avLst/>
+          </a:prstGeom>
+          <a:ln w="28575">
+            <a:solidFill>
+              <a:schemeClr val="accent2"/>
+            </a:solidFill>
+          </a:ln>
+        </p:spPr>
+      </p:pic>
+    </p:spTree>
+    <p:extLst>
+      <p:ext uri="{BB962C8B-B14F-4D97-AF65-F5344CB8AC3E}">
+        <p14:creationId xmlns:p14="http://schemas.microsoft.com/office/powerpoint/2010/main" val="3713997872"/>
+      </p:ext>
+    </p:extLst>
+  </p:cSld>
+  <p:clrMapOvr>
+    <a:masterClrMapping/>
+  </p:clrMapOvr>
+</p:sld>
+</file>
+
+<file path=ppt/slides/slide12.xml><?xml version="1.0" encoding="utf-8"?>
+<p:sld xmlns:a="http://schemas.openxmlformats.org/drawingml/2006/main" xmlns:r="http://schemas.openxmlformats.org/officeDocument/2006/relationships" xmlns:p="http://schemas.openxmlformats.org/presentationml/2006/main">
+  <p:cSld>
+    <p:bg>
+      <p:bgPr>
+        <a:solidFill>
+          <a:schemeClr val="bg1"/>
+        </a:solidFill>
+        <a:effectLst/>
+      </p:bgPr>
+    </p:bg>
+    <p:spTree>
+      <p:nvGrpSpPr>
         <p:cNvPr id="1" name=""/>
         <p:cNvGrpSpPr/>
         <p:nvPr/>
@@ -12305,7 +13535,10 @@
               <a:buFont typeface="+mj-lt"/>
               <a:buAutoNum type="arabicPeriod"/>
             </a:pPr>
-            <a:endParaRPr lang="en-US" dirty="0"/>
+            <a:r>
+              <a:rPr lang="en-US" dirty="0"/>
+              <a:t>User testing + feedback</a:t>
+            </a:r>
           </a:p>
         </p:txBody>
       </p:sp>
@@ -15169,6 +16402,20 @@
               <a:buFont typeface="+mj-lt"/>
               <a:buAutoNum type="arabicPeriod"/>
             </a:pPr>
+            <a:r>
+              <a:rPr lang="en-US" sz="2000" dirty="0">
+                <a:solidFill>
+                  <a:schemeClr val="tx1"/>
+                </a:solidFill>
+              </a:rPr>
+              <a:t>Email Password Recovery - Backend</a:t>
+            </a:r>
+          </a:p>
+          <a:p>
+            <a:pPr marL="342900" indent="-342900">
+              <a:buFont typeface="+mj-lt"/>
+              <a:buAutoNum type="arabicPeriod"/>
+            </a:pPr>
             <a:endParaRPr lang="en-US" sz="2000" dirty="0">
               <a:solidFill>
                 <a:schemeClr val="tx1"/>
@@ -15763,6 +17010,20 @@
             </a:r>
           </a:p>
           <a:p>
+            <a:pPr marL="342900" indent="-342900">
+              <a:buFont typeface="+mj-lt"/>
+              <a:buAutoNum type="arabicPeriod"/>
+            </a:pPr>
+            <a:r>
+              <a:rPr lang="en-US" sz="2000" dirty="0">
+                <a:solidFill>
+                  <a:schemeClr val="tx1"/>
+                </a:solidFill>
+              </a:rPr>
+              <a:t>Still being worked on</a:t>
+            </a:r>
+          </a:p>
+          <a:p>
             <a:endParaRPr lang="en-US" sz="2000" dirty="0">
               <a:solidFill>
                 <a:schemeClr val="tx1"/>
@@ -16186,7 +17447,7 @@
         <p:cNvPr id="1" name="">
           <a:extLst>
             <a:ext uri="{FF2B5EF4-FFF2-40B4-BE49-F238E27FC236}">
-              <a16:creationId xmlns:a16="http://schemas.microsoft.com/office/drawing/2014/main" id="{38138CFD-A501-8AEC-C666-BED845111F6D}"/>
+              <a16:creationId xmlns:a16="http://schemas.microsoft.com/office/drawing/2014/main" id="{EF9137CD-4CC9-5BD4-6E38-2A0F76C1E94C}"/>
             </a:ext>
           </a:extLst>
         </p:cNvPr>
@@ -16203,10 +17464,10 @@
       </p:grpSpPr>
       <p:sp useBgFill="1">
         <p:nvSpPr>
-          <p:cNvPr id="21" name="Rectangle 20">
+          <p:cNvPr id="23" name="Rectangle 22">
             <a:extLst>
               <a:ext uri="{FF2B5EF4-FFF2-40B4-BE49-F238E27FC236}">
-                <a16:creationId xmlns:a16="http://schemas.microsoft.com/office/drawing/2014/main" id="{356F68EF-088F-20DD-B4B1-6BCF0A8C9BF2}"/>
+                <a16:creationId xmlns:a16="http://schemas.microsoft.com/office/drawing/2014/main" id="{1535E14E-A87E-A51E-38D5-AF2343AED4BE}"/>
               </a:ext>
               <a:ext uri="{C183D7F6-B498-43B3-948B-1728B52AA6E4}">
                 <adec:decorative xmlns:adec="http://schemas.microsoft.com/office/drawing/2017/decorative" val="1"/>
@@ -16227,11 +17488,100 @@
         <p:spPr>
           <a:xfrm>
             <a:off x="0" y="0"/>
-            <a:ext cx="12191999" cy="6857365"/>
+            <a:ext cx="12192000" cy="6858000"/>
           </a:xfrm>
           <a:prstGeom prst="rect">
             <a:avLst/>
           </a:prstGeom>
+          <a:ln w="12700" cap="flat" cmpd="sng" algn="ctr">
+            <a:noFill/>
+            <a:prstDash val="solid"/>
+            <a:miter lim="800000"/>
+          </a:ln>
+          <a:effectLst/>
+          <a:extLst>
+            <a:ext uri="{91240B29-F687-4F45-9708-019B960494DF}">
+              <a14:hiddenLine xmlns:a14="http://schemas.microsoft.com/office/drawing/2010/main" w="12700" cap="flat" cmpd="sng" algn="ctr">
+                <a:solidFill>
+                  <a:schemeClr val="accent1">
+                    <a:shade val="50000"/>
+                  </a:schemeClr>
+                </a:solidFill>
+                <a:prstDash val="solid"/>
+                <a:miter lim="800000"/>
+              </a14:hiddenLine>
+            </a:ext>
+          </a:extLst>
+        </p:spPr>
+        <p:style>
+          <a:lnRef idx="2">
+            <a:schemeClr val="accent1">
+              <a:shade val="50000"/>
+            </a:schemeClr>
+          </a:lnRef>
+          <a:fillRef idx="1">
+            <a:schemeClr val="accent1"/>
+          </a:fillRef>
+          <a:effectRef idx="0">
+            <a:schemeClr val="accent1"/>
+          </a:effectRef>
+          <a:fontRef idx="minor">
+            <a:schemeClr val="lt1"/>
+          </a:fontRef>
+        </p:style>
+        <p:txBody>
+          <a:bodyPr rtlCol="0" anchor="ctr"/>
+          <a:lstStyle/>
+          <a:p>
+            <a:pPr algn="ctr"/>
+            <a:endParaRPr lang="en-US"/>
+          </a:p>
+        </p:txBody>
+      </p:sp>
+      <p:sp>
+        <p:nvSpPr>
+          <p:cNvPr id="25" name="Rectangle 24">
+            <a:extLst>
+              <a:ext uri="{FF2B5EF4-FFF2-40B4-BE49-F238E27FC236}">
+                <a16:creationId xmlns:a16="http://schemas.microsoft.com/office/drawing/2014/main" id="{5C028681-22BB-4B90-341B-0F619999EBD5}"/>
+              </a:ext>
+              <a:ext uri="{C183D7F6-B498-43B3-948B-1728B52AA6E4}">
+                <adec:decorative xmlns:adec="http://schemas.microsoft.com/office/drawing/2017/decorative" val="1"/>
+              </a:ext>
+            </a:extLst>
+          </p:cNvPr>
+          <p:cNvSpPr>
+            <a:spLocks noGrp="1" noRot="1" noChangeAspect="1" noMove="1" noResize="1" noEditPoints="1" noAdjustHandles="1" noChangeArrowheads="1" noChangeShapeType="1" noTextEdit="1"/>
+          </p:cNvSpPr>
+          <p:nvPr>
+            <p:extLst>
+              <p:ext uri="{386F3935-93C4-4BCD-93E2-E3B085C9AB24}">
+                <p16:designElem xmlns:p16="http://schemas.microsoft.com/office/powerpoint/2015/main" val="1"/>
+              </p:ext>
+            </p:extLst>
+          </p:nvPr>
+        </p:nvSpPr>
+        <p:spPr>
+          <a:xfrm rot="5400000" flipH="1">
+            <a:off x="-1417539" y="1417538"/>
+            <a:ext cx="6875818" cy="4040744"/>
+          </a:xfrm>
+          <a:prstGeom prst="rect">
+            <a:avLst/>
+          </a:prstGeom>
+          <a:gradFill>
+            <a:gsLst>
+              <a:gs pos="0">
+                <a:srgbClr val="000000"/>
+              </a:gs>
+              <a:gs pos="100000">
+                <a:schemeClr val="accent1">
+                  <a:lumMod val="75000"/>
+                </a:schemeClr>
+              </a:gs>
+            </a:gsLst>
+            <a:lin ang="18600000" scaled="0"/>
+          </a:gradFill>
           <a:ln>
             <a:noFill/>
           </a:ln>
@@ -16257,16 +17607,16 @@
           <a:lstStyle/>
           <a:p>
             <a:pPr algn="ctr"/>
-            <a:endParaRPr lang="en-US"/>
+            <a:endParaRPr lang="en-US" dirty="0"/>
           </a:p>
         </p:txBody>
       </p:sp>
       <p:sp>
         <p:nvSpPr>
-          <p:cNvPr id="22" name="Rectangle 21">
+          <p:cNvPr id="27" name="Rectangle 26">
             <a:extLst>
               <a:ext uri="{FF2B5EF4-FFF2-40B4-BE49-F238E27FC236}">
-                <a16:creationId xmlns:a16="http://schemas.microsoft.com/office/drawing/2014/main" id="{9EF082FE-D96F-0D2A-34AA-F987D0796D34}"/>
+                <a16:creationId xmlns:a16="http://schemas.microsoft.com/office/drawing/2014/main" id="{E065C57B-648A-799E-D23C-BEDE7985B85E}"/>
               </a:ext>
               <a:ext uri="{C183D7F6-B498-43B3-948B-1728B52AA6E4}">
                 <adec:decorative xmlns:adec="http://schemas.microsoft.com/office/drawing/2017/decorative" val="1"/>
@@ -16285,16 +17635,29 @@
           </p:nvPr>
         </p:nvSpPr>
         <p:spPr>
-          <a:xfrm>
-            <a:off x="0" y="1"/>
-            <a:ext cx="12192000" cy="5187142"/>
+          <a:xfrm rot="16200000">
+            <a:off x="-158495" y="2660473"/>
+            <a:ext cx="4355594" cy="4038603"/>
           </a:xfrm>
           <a:prstGeom prst="rect">
             <a:avLst/>
           </a:prstGeom>
-          <a:solidFill>
-            <a:schemeClr val="accent4"/>
-          </a:solidFill>
+          <a:gradFill>
+            <a:gsLst>
+              <a:gs pos="0">
+                <a:schemeClr val="accent1">
+                  <a:alpha val="50000"/>
+                </a:schemeClr>
+              </a:gs>
+              <a:gs pos="100000">
+                <a:schemeClr val="accent1">
+                  <a:lumMod val="50000"/>
+                  <a:alpha val="0"/>
+                </a:schemeClr>
+              </a:gs>
+            </a:gsLst>
+            <a:lin ang="11400000" scaled="0"/>
+          </a:gradFill>
           <a:ln>
             <a:noFill/>
           </a:ln>
@@ -16320,16 +17683,16 @@
           <a:lstStyle/>
           <a:p>
             <a:pPr algn="ctr"/>
-            <a:endParaRPr lang="en-US" dirty="0"/>
+            <a:endParaRPr lang="en-US"/>
           </a:p>
         </p:txBody>
       </p:sp>
       <p:sp>
         <p:nvSpPr>
-          <p:cNvPr id="23" name="Rectangle 22">
+          <p:cNvPr id="29" name="Rectangle 28">
             <a:extLst>
               <a:ext uri="{FF2B5EF4-FFF2-40B4-BE49-F238E27FC236}">
-                <a16:creationId xmlns:a16="http://schemas.microsoft.com/office/drawing/2014/main" id="{0BE13FF0-F6F1-375E-D271-70DAE72E1AC7}"/>
+                <a16:creationId xmlns:a16="http://schemas.microsoft.com/office/drawing/2014/main" id="{65AA6206-9EE0-995C-B913-B1FF874D2758}"/>
               </a:ext>
               <a:ext uri="{C183D7F6-B498-43B3-948B-1728B52AA6E4}">
                 <adec:decorative xmlns:adec="http://schemas.microsoft.com/office/drawing/2017/decorative" val="1"/>
@@ -16348,26 +17711,31 @@
           </p:nvPr>
         </p:nvSpPr>
         <p:spPr>
-          <a:xfrm>
-            <a:off x="596464" y="551961"/>
-            <a:ext cx="10999072" cy="5399950"/>
+          <a:xfrm rot="16200000" flipH="1">
+            <a:off x="-1180882" y="1638085"/>
+            <a:ext cx="6857572" cy="3581401"/>
           </a:xfrm>
           <a:prstGeom prst="rect">
             <a:avLst/>
           </a:prstGeom>
-          <a:solidFill>
-            <a:schemeClr val="bg1"/>
-          </a:solidFill>
+          <a:gradFill>
+            <a:gsLst>
+              <a:gs pos="0">
+                <a:srgbClr val="000000">
+                  <a:alpha val="59000"/>
+                </a:srgbClr>
+              </a:gs>
+              <a:gs pos="69000">
+                <a:schemeClr val="accent1">
+                  <a:alpha val="0"/>
+                </a:schemeClr>
+              </a:gs>
+            </a:gsLst>
+            <a:lin ang="13200000" scaled="0"/>
+          </a:gradFill>
           <a:ln>
             <a:noFill/>
           </a:ln>
-          <a:effectLst>
-            <a:outerShdw blurRad="139700" dist="127000" dir="5400000" algn="t" rotWithShape="0">
-              <a:prstClr val="black">
-                <a:alpha val="15000"/>
-              </a:prstClr>
-            </a:outerShdw>
-          </a:effectLst>
         </p:spPr>
         <p:style>
           <a:lnRef idx="2">
@@ -16390,25 +17758,25 @@
           <a:lstStyle/>
           <a:p>
             <a:pPr algn="ctr"/>
-            <a:endParaRPr lang="en-US"/>
+            <a:endParaRPr lang="en-US" dirty="0"/>
           </a:p>
         </p:txBody>
       </p:sp>
-      <p:cxnSp>
-        <p:nvCxnSpPr>
-          <p:cNvPr id="25" name="Straight Connector 24">
+      <p:sp>
+        <p:nvSpPr>
+          <p:cNvPr id="31" name="Freeform: Shape 30">
             <a:extLst>
               <a:ext uri="{FF2B5EF4-FFF2-40B4-BE49-F238E27FC236}">
-                <a16:creationId xmlns:a16="http://schemas.microsoft.com/office/drawing/2014/main" id="{3A7F67B2-22A5-7F2D-13EB-E06229F5CB46}"/>
+                <a16:creationId xmlns:a16="http://schemas.microsoft.com/office/drawing/2014/main" id="{526FDD80-6D5E-1A4E-BFF1-07991F1FA583}"/>
               </a:ext>
               <a:ext uri="{C183D7F6-B498-43B3-948B-1728B52AA6E4}">
                 <adec:decorative xmlns:adec="http://schemas.microsoft.com/office/drawing/2017/decorative" val="1"/>
               </a:ext>
             </a:extLst>
           </p:cNvPr>
-          <p:cNvCxnSpPr>
-            <a:cxnSpLocks noGrp="1" noRot="1" noChangeAspect="1" noMove="1" noResize="1" noEditPoints="1" noAdjustHandles="1" noChangeArrowheads="1" noChangeShapeType="1"/>
-          </p:cNvCxnSpPr>
+          <p:cNvSpPr>
+            <a:spLocks noGrp="1" noRot="1" noChangeAspect="1" noMove="1" noResize="1" noEditPoints="1" noAdjustHandles="1" noChangeArrowheads="1" noChangeShapeType="1" noTextEdit="1"/>
+          </p:cNvSpPr>
           <p:nvPr>
             <p:extLst>
               <p:ext uri="{386F3935-93C4-4BCD-93E2-E3B085C9AB24}">
@@ -16416,42 +17784,163 @@
               </p:ext>
             </p:extLst>
           </p:nvPr>
-        </p:nvCxnSpPr>
+        </p:nvSpPr>
         <p:spPr>
-          <a:xfrm flipH="1">
-            <a:off x="596464" y="6329769"/>
-            <a:ext cx="11000232" cy="0"/>
+          <a:xfrm rot="6097846">
+            <a:off x="-747355" y="1201312"/>
+            <a:ext cx="4808302" cy="4088666"/>
           </a:xfrm>
-          <a:prstGeom prst="line">
+          <a:custGeom>
             <a:avLst/>
-          </a:prstGeom>
-          <a:ln w="152400">
-            <a:solidFill>
-              <a:schemeClr val="accent4"/>
-            </a:solidFill>
+            <a:gdLst>
+              <a:gd name="connsiteX0" fmla="*/ 48844 w 4808302"/>
+              <a:gd name="connsiteY0" fmla="*/ 2888671 h 4088666"/>
+              <a:gd name="connsiteX1" fmla="*/ 0 w 4808302"/>
+              <a:gd name="connsiteY1" fmla="*/ 2404151 h 4088666"/>
+              <a:gd name="connsiteX2" fmla="*/ 2404151 w 4808302"/>
+              <a:gd name="connsiteY2" fmla="*/ 0 h 4088666"/>
+              <a:gd name="connsiteX3" fmla="*/ 4808302 w 4808302"/>
+              <a:gd name="connsiteY3" fmla="*/ 2404151 h 4088666"/>
+              <a:gd name="connsiteX4" fmla="*/ 4700216 w 4808302"/>
+              <a:gd name="connsiteY4" fmla="*/ 3119072 h 4088666"/>
+              <a:gd name="connsiteX5" fmla="*/ 4643143 w 4808302"/>
+              <a:gd name="connsiteY5" fmla="*/ 3275009 h 4088666"/>
+              <a:gd name="connsiteX6" fmla="*/ 690093 w 4808302"/>
+              <a:gd name="connsiteY6" fmla="*/ 4088666 h 4088666"/>
+              <a:gd name="connsiteX7" fmla="*/ 548991 w 4808302"/>
+              <a:gd name="connsiteY7" fmla="*/ 3933414 h 4088666"/>
+              <a:gd name="connsiteX8" fmla="*/ 48844 w 4808302"/>
+              <a:gd name="connsiteY8" fmla="*/ 2888671 h 4088666"/>
+            </a:gdLst>
+            <a:ahLst/>
+            <a:cxnLst>
+              <a:cxn ang="0">
+                <a:pos x="connsiteX0" y="connsiteY0"/>
+              </a:cxn>
+              <a:cxn ang="0">
+                <a:pos x="connsiteX1" y="connsiteY1"/>
+              </a:cxn>
+              <a:cxn ang="0">
+                <a:pos x="connsiteX2" y="connsiteY2"/>
+              </a:cxn>
+              <a:cxn ang="0">
+                <a:pos x="connsiteX3" y="connsiteY3"/>
+              </a:cxn>
+              <a:cxn ang="0">
+                <a:pos x="connsiteX4" y="connsiteY4"/>
+              </a:cxn>
+              <a:cxn ang="0">
+                <a:pos x="connsiteX5" y="connsiteY5"/>
+              </a:cxn>
+              <a:cxn ang="0">
+                <a:pos x="connsiteX6" y="connsiteY6"/>
+              </a:cxn>
+              <a:cxn ang="0">
+                <a:pos x="connsiteX7" y="connsiteY7"/>
+              </a:cxn>
+              <a:cxn ang="0">
+                <a:pos x="connsiteX8" y="connsiteY8"/>
+              </a:cxn>
+            </a:cxnLst>
+            <a:rect l="l" t="t" r="r" b="b"/>
+            <a:pathLst>
+              <a:path w="4808302" h="4088666">
+                <a:moveTo>
+                  <a:pt x="48844" y="2888671"/>
+                </a:moveTo>
+                <a:cubicBezTo>
+                  <a:pt x="16818" y="2732167"/>
+                  <a:pt x="0" y="2570123"/>
+                  <a:pt x="0" y="2404151"/>
+                </a:cubicBezTo>
+                <a:cubicBezTo>
+                  <a:pt x="0" y="1076375"/>
+                  <a:pt x="1076375" y="0"/>
+                  <a:pt x="2404151" y="0"/>
+                </a:cubicBezTo>
+                <a:cubicBezTo>
+                  <a:pt x="3731927" y="0"/>
+                  <a:pt x="4808302" y="1076375"/>
+                  <a:pt x="4808302" y="2404151"/>
+                </a:cubicBezTo>
+                <a:cubicBezTo>
+                  <a:pt x="4808302" y="2653109"/>
+                  <a:pt x="4770461" y="2893229"/>
+                  <a:pt x="4700216" y="3119072"/>
+                </a:cubicBezTo>
+                <a:lnTo>
+                  <a:pt x="4643143" y="3275009"/>
+                </a:lnTo>
+                <a:lnTo>
+                  <a:pt x="690093" y="4088666"/>
+                </a:lnTo>
+                <a:lnTo>
+                  <a:pt x="548991" y="3933414"/>
+                </a:lnTo>
+                <a:cubicBezTo>
+                  <a:pt x="304015" y="3636572"/>
+                  <a:pt x="128908" y="3279932"/>
+                  <a:pt x="48844" y="2888671"/>
+                </a:cubicBezTo>
+                <a:close/>
+              </a:path>
+            </a:pathLst>
+          </a:custGeom>
+          <a:gradFill>
+            <a:gsLst>
+              <a:gs pos="39000">
+                <a:schemeClr val="accent1">
+                  <a:lumMod val="60000"/>
+                  <a:lumOff val="40000"/>
+                  <a:alpha val="0"/>
+                </a:schemeClr>
+              </a:gs>
+              <a:gs pos="100000">
+                <a:schemeClr val="accent1">
+                  <a:lumMod val="75000"/>
+                  <a:alpha val="26000"/>
+                </a:schemeClr>
+              </a:gs>
+            </a:gsLst>
+            <a:lin ang="18600000" scaled="0"/>
+          </a:gradFill>
+          <a:ln>
+            <a:noFill/>
           </a:ln>
         </p:spPr>
         <p:style>
-          <a:lnRef idx="1">
-            <a:schemeClr val="accent1"/>
+          <a:lnRef idx="2">
+            <a:schemeClr val="accent1">
+              <a:shade val="50000"/>
+            </a:schemeClr>
           </a:lnRef>
-          <a:fillRef idx="0">
+          <a:fillRef idx="1">
             <a:schemeClr val="accent1"/>
           </a:fillRef>
           <a:effectRef idx="0">
             <a:schemeClr val="accent1"/>
           </a:effectRef>
           <a:fontRef idx="minor">
-            <a:schemeClr val="tx1"/>
+            <a:schemeClr val="lt1"/>
           </a:fontRef>
         </p:style>
-      </p:cxnSp>
+        <p:txBody>
+          <a:bodyPr wrap="square" rtlCol="0" anchor="ctr">
+            <a:noAutofit/>
+          </a:bodyPr>
+          <a:lstStyle/>
+          <a:p>
+            <a:pPr algn="ctr"/>
+            <a:endParaRPr lang="en-US" dirty="0"/>
+          </a:p>
+        </p:txBody>
+      </p:sp>
       <p:sp>
         <p:nvSpPr>
-          <p:cNvPr id="9" name="Title 1">
+          <p:cNvPr id="2" name="Title 1">
             <a:extLst>
               <a:ext uri="{FF2B5EF4-FFF2-40B4-BE49-F238E27FC236}">
-                <a16:creationId xmlns:a16="http://schemas.microsoft.com/office/drawing/2014/main" id="{D6D36DC8-D9BF-8C26-69EA-ED89E34DB644}"/>
+                <a16:creationId xmlns:a16="http://schemas.microsoft.com/office/drawing/2014/main" id="{E7ADF079-FAEB-82AB-5AAA-BCCDB807CC00}"/>
               </a:ext>
             </a:extLst>
           </p:cNvPr>
@@ -16464,57 +17953,114 @@
         </p:nvSpPr>
         <p:spPr>
           <a:xfrm>
-            <a:off x="4008559" y="768350"/>
-            <a:ext cx="4162181" cy="920920"/>
+            <a:off x="660041" y="2767106"/>
+            <a:ext cx="2880828" cy="3071906"/>
           </a:xfrm>
         </p:spPr>
         <p:txBody>
-          <a:bodyPr/>
+          <a:bodyPr vert="horz" lIns="91440" tIns="45720" rIns="91440" bIns="45720" rtlCol="0" anchor="t">
+            <a:normAutofit/>
+          </a:bodyPr>
           <a:lstStyle/>
           <a:p>
             <a:r>
-              <a:rPr lang="en-US"/>
-              <a:t>Week 8 </a:t>
+              <a:rPr lang="en-US" sz="3700" dirty="0">
+                <a:solidFill>
+                  <a:srgbClr val="FFFFFF"/>
+                </a:solidFill>
+              </a:rPr>
+              <a:t>Reset Password</a:t>
             </a:r>
+            <a:br>
+              <a:rPr lang="en-US" sz="3700" dirty="0">
+                <a:solidFill>
+                  <a:srgbClr val="FFFFFF"/>
+                </a:solidFill>
+              </a:rPr>
+            </a:br>
             <a:r>
-              <a:rPr lang="en-US" dirty="0"/>
-              <a:t>Plan</a:t>
+              <a:rPr lang="en-US" sz="3700" dirty="0">
+                <a:solidFill>
+                  <a:srgbClr val="FFFFFF"/>
+                </a:solidFill>
+              </a:rPr>
+              <a:t>Recovery</a:t>
             </a:r>
+            <a:endParaRPr lang="en-US" sz="3700" kern="1200" dirty="0">
+              <a:solidFill>
+                <a:srgbClr val="FFFFFF"/>
+              </a:solidFill>
+              <a:latin typeface="+mj-lt"/>
+              <a:ea typeface="+mj-ea"/>
+              <a:cs typeface="+mj-cs"/>
+            </a:endParaRPr>
           </a:p>
         </p:txBody>
       </p:sp>
-      <p:graphicFrame>
-        <p:nvGraphicFramePr>
-          <p:cNvPr id="27" name="Text Placeholder 2">
+      <p:pic>
+        <p:nvPicPr>
+          <p:cNvPr id="6" name="Picture 5">
             <a:extLst>
               <a:ext uri="{FF2B5EF4-FFF2-40B4-BE49-F238E27FC236}">
-                <a16:creationId xmlns:a16="http://schemas.microsoft.com/office/drawing/2014/main" id="{D6B93F0B-FEB0-EDAB-CFE1-A57DEFE97FCD}"/>
+                <a16:creationId xmlns:a16="http://schemas.microsoft.com/office/drawing/2014/main" id="{6BE273B2-F117-7B45-075E-81A1E11AEF51}"/>
               </a:ext>
             </a:extLst>
           </p:cNvPr>
-          <p:cNvGraphicFramePr/>
-          <p:nvPr>
-            <p:extLst>
-              <p:ext uri="{D42A27DB-BD31-4B8C-83A1-F6EECF244321}">
-                <p14:modId xmlns:p14="http://schemas.microsoft.com/office/powerpoint/2010/main" val="941069956"/>
-              </p:ext>
-            </p:extLst>
-          </p:nvPr>
-        </p:nvGraphicFramePr>
-        <p:xfrm>
-          <a:off x="838199" y="2688113"/>
-          <a:ext cx="10515600" cy="3050990"/>
-        </p:xfrm>
-        <a:graphic>
-          <a:graphicData uri="http://schemas.openxmlformats.org/drawingml/2006/diagram">
-            <dgm:relIds xmlns:dgm="http://schemas.openxmlformats.org/drawingml/2006/diagram" xmlns:r="http://schemas.openxmlformats.org/officeDocument/2006/relationships" r:dm="rId2" r:lo="rId3" r:qs="rId4" r:cs="rId5"/>
-          </a:graphicData>
-        </a:graphic>
-      </p:graphicFrame>
+          <p:cNvPicPr>
+            <a:picLocks noChangeAspect="1"/>
+          </p:cNvPicPr>
+          <p:nvPr/>
+        </p:nvPicPr>
+        <p:blipFill>
+          <a:blip r:embed="rId2"/>
+          <a:stretch>
+            <a:fillRect/>
+          </a:stretch>
+        </p:blipFill>
+        <p:spPr>
+          <a:xfrm>
+            <a:off x="6627933" y="156394"/>
+            <a:ext cx="3330229" cy="1912786"/>
+          </a:xfrm>
+          <a:prstGeom prst="rect">
+            <a:avLst/>
+          </a:prstGeom>
+        </p:spPr>
+      </p:pic>
+      <p:pic>
+        <p:nvPicPr>
+          <p:cNvPr id="8" name="Picture 7">
+            <a:extLst>
+              <a:ext uri="{FF2B5EF4-FFF2-40B4-BE49-F238E27FC236}">
+                <a16:creationId xmlns:a16="http://schemas.microsoft.com/office/drawing/2014/main" id="{A9A65ADA-C7D0-4668-D0C0-B864E947F509}"/>
+              </a:ext>
+            </a:extLst>
+          </p:cNvPr>
+          <p:cNvPicPr>
+            <a:picLocks noChangeAspect="1"/>
+          </p:cNvPicPr>
+          <p:nvPr/>
+        </p:nvPicPr>
+        <p:blipFill>
+          <a:blip r:embed="rId3"/>
+          <a:stretch>
+            <a:fillRect/>
+          </a:stretch>
+        </p:blipFill>
+        <p:spPr>
+          <a:xfrm>
+            <a:off x="5294317" y="2225574"/>
+            <a:ext cx="5997460" cy="4397121"/>
+          </a:xfrm>
+          <a:prstGeom prst="rect">
+            <a:avLst/>
+          </a:prstGeom>
+        </p:spPr>
+      </p:pic>
     </p:spTree>
     <p:extLst>
       <p:ext uri="{BB962C8B-B14F-4D97-AF65-F5344CB8AC3E}">
-        <p14:creationId xmlns:p14="http://schemas.microsoft.com/office/powerpoint/2010/main" val="2561402868"/>
+        <p14:creationId xmlns:p14="http://schemas.microsoft.com/office/powerpoint/2010/main" val="1279643669"/>
       </p:ext>
     </p:extLst>
   </p:cSld>
@@ -16551,10 +18097,10 @@
       </p:grpSpPr>
       <p:sp useBgFill="1">
         <p:nvSpPr>
-          <p:cNvPr id="28" name="Rectangle 27">
+          <p:cNvPr id="23" name="Rectangle 22">
             <a:extLst>
               <a:ext uri="{FF2B5EF4-FFF2-40B4-BE49-F238E27FC236}">
-                <a16:creationId xmlns:a16="http://schemas.microsoft.com/office/drawing/2014/main" id="{C1A1C5D3-C053-4EE9-BE1A-419B6E27CCAE}"/>
+                <a16:creationId xmlns:a16="http://schemas.microsoft.com/office/drawing/2014/main" id="{A8384FB5-9ADC-4DDC-881B-597D56F5B15D}"/>
               </a:ext>
               <a:ext uri="{C183D7F6-B498-43B3-948B-1728B52AA6E4}">
                 <adec:decorative xmlns:adec="http://schemas.microsoft.com/office/drawing/2017/decorative" val="1"/>
@@ -16580,6 +18126,95 @@
           <a:prstGeom prst="rect">
             <a:avLst/>
           </a:prstGeom>
+          <a:ln w="12700" cap="flat" cmpd="sng" algn="ctr">
+            <a:noFill/>
+            <a:prstDash val="solid"/>
+            <a:miter lim="800000"/>
+          </a:ln>
+          <a:effectLst/>
+          <a:extLst>
+            <a:ext uri="{91240B29-F687-4F45-9708-019B960494DF}">
+              <a14:hiddenLine xmlns:a14="http://schemas.microsoft.com/office/drawing/2010/main" w="12700" cap="flat" cmpd="sng" algn="ctr">
+                <a:solidFill>
+                  <a:schemeClr val="accent1">
+                    <a:shade val="50000"/>
+                  </a:schemeClr>
+                </a:solidFill>
+                <a:prstDash val="solid"/>
+                <a:miter lim="800000"/>
+              </a14:hiddenLine>
+            </a:ext>
+          </a:extLst>
+        </p:spPr>
+        <p:style>
+          <a:lnRef idx="2">
+            <a:schemeClr val="accent1">
+              <a:shade val="50000"/>
+            </a:schemeClr>
+          </a:lnRef>
+          <a:fillRef idx="1">
+            <a:schemeClr val="accent1"/>
+          </a:fillRef>
+          <a:effectRef idx="0">
+            <a:schemeClr val="accent1"/>
+          </a:effectRef>
+          <a:fontRef idx="minor">
+            <a:schemeClr val="lt1"/>
+          </a:fontRef>
+        </p:style>
+        <p:txBody>
+          <a:bodyPr rtlCol="0" anchor="ctr"/>
+          <a:lstStyle/>
+          <a:p>
+            <a:pPr algn="ctr"/>
+            <a:endParaRPr lang="en-US"/>
+          </a:p>
+        </p:txBody>
+      </p:sp>
+      <p:sp>
+        <p:nvSpPr>
+          <p:cNvPr id="25" name="Rectangle 24">
+            <a:extLst>
+              <a:ext uri="{FF2B5EF4-FFF2-40B4-BE49-F238E27FC236}">
+                <a16:creationId xmlns:a16="http://schemas.microsoft.com/office/drawing/2014/main" id="{91E5A9A7-95C6-4F4F-B00E-C82E07FE62EF}"/>
+              </a:ext>
+              <a:ext uri="{C183D7F6-B498-43B3-948B-1728B52AA6E4}">
+                <adec:decorative xmlns:adec="http://schemas.microsoft.com/office/drawing/2017/decorative" val="1"/>
+              </a:ext>
+            </a:extLst>
+          </p:cNvPr>
+          <p:cNvSpPr>
+            <a:spLocks noGrp="1" noRot="1" noChangeAspect="1" noMove="1" noResize="1" noEditPoints="1" noAdjustHandles="1" noChangeArrowheads="1" noChangeShapeType="1" noTextEdit="1"/>
+          </p:cNvSpPr>
+          <p:nvPr>
+            <p:extLst>
+              <p:ext uri="{386F3935-93C4-4BCD-93E2-E3B085C9AB24}">
+                <p16:designElem xmlns:p16="http://schemas.microsoft.com/office/powerpoint/2015/main" val="1"/>
+              </p:ext>
+            </p:extLst>
+          </p:nvPr>
+        </p:nvSpPr>
+        <p:spPr>
+          <a:xfrm rot="5400000" flipH="1">
+            <a:off x="-1417539" y="1417538"/>
+            <a:ext cx="6875818" cy="4040744"/>
+          </a:xfrm>
+          <a:prstGeom prst="rect">
+            <a:avLst/>
+          </a:prstGeom>
+          <a:gradFill>
+            <a:gsLst>
+              <a:gs pos="0">
+                <a:srgbClr val="000000"/>
+              </a:gs>
+              <a:gs pos="100000">
+                <a:schemeClr val="accent1">
+                  <a:lumMod val="75000"/>
+                </a:schemeClr>
+              </a:gs>
+            </a:gsLst>
+            <a:lin ang="18600000" scaled="0"/>
+          </a:gradFill>
           <a:ln>
             <a:noFill/>
           </a:ln>
@@ -16605,16 +18240,16 @@
           <a:lstStyle/>
           <a:p>
             <a:pPr algn="ctr"/>
-            <a:endParaRPr lang="en-US"/>
+            <a:endParaRPr lang="en-US" dirty="0"/>
           </a:p>
         </p:txBody>
       </p:sp>
-      <p:sp useBgFill="1">
+      <p:sp>
         <p:nvSpPr>
-          <p:cNvPr id="30" name="Rectangle 29">
+          <p:cNvPr id="27" name="Rectangle 26">
             <a:extLst>
               <a:ext uri="{FF2B5EF4-FFF2-40B4-BE49-F238E27FC236}">
-                <a16:creationId xmlns:a16="http://schemas.microsoft.com/office/drawing/2014/main" id="{A3473CF9-37EB-43E7-89EF-D2D1C53D1DAC}"/>
+                <a16:creationId xmlns:a16="http://schemas.microsoft.com/office/drawing/2014/main" id="{D07DD2DE-F619-49DD-B5E7-03A290FF4ED1}"/>
               </a:ext>
               <a:ext uri="{C183D7F6-B498-43B3-948B-1728B52AA6E4}">
                 <adec:decorative xmlns:adec="http://schemas.microsoft.com/office/drawing/2017/decorative" val="1"/>
@@ -16633,160 +18268,29 @@
           </p:nvPr>
         </p:nvSpPr>
         <p:spPr>
-          <a:xfrm>
-            <a:off x="1903615" y="221673"/>
-            <a:ext cx="8384770" cy="1332634"/>
+          <a:xfrm rot="16200000">
+            <a:off x="-158495" y="2660473"/>
+            <a:ext cx="4355594" cy="4038603"/>
           </a:xfrm>
           <a:prstGeom prst="rect">
             <a:avLst/>
           </a:prstGeom>
-          <a:ln w="12700">
-            <a:solidFill>
-              <a:srgbClr val="E1E1E1"/>
-            </a:solidFill>
-          </a:ln>
-          <a:effectLst>
-            <a:outerShdw blurRad="50800" dist="38100" dir="2700000" algn="tl" rotWithShape="0">
-              <a:schemeClr val="bg2">
-                <a:lumMod val="85000"/>
-                <a:alpha val="50000"/>
-              </a:schemeClr>
-            </a:outerShdw>
-          </a:effectLst>
-        </p:spPr>
-        <p:style>
-          <a:lnRef idx="2">
-            <a:schemeClr val="accent1">
-              <a:shade val="50000"/>
-            </a:schemeClr>
-          </a:lnRef>
-          <a:fillRef idx="1">
-            <a:schemeClr val="accent1"/>
-          </a:fillRef>
-          <a:effectRef idx="0">
-            <a:schemeClr val="accent1"/>
-          </a:effectRef>
-          <a:fontRef idx="minor">
-            <a:schemeClr val="lt1"/>
-          </a:fontRef>
-        </p:style>
-        <p:txBody>
-          <a:bodyPr rtlCol="0" anchor="ctr"/>
-          <a:lstStyle/>
-          <a:p>
-            <a:pPr marL="0" marR="0" lvl="0" indent="0" algn="ctr" defTabSz="914400" rtl="0" eaLnBrk="1" fontAlgn="auto" latinLnBrk="0" hangingPunct="1">
-              <a:lnSpc>
-                <a:spcPct val="100000"/>
-              </a:lnSpc>
-              <a:spcBef>
-                <a:spcPts val="0"/>
-              </a:spcBef>
-              <a:spcAft>
-                <a:spcPts val="0"/>
-              </a:spcAft>
-              <a:buClrTx/>
-              <a:buSzTx/>
-              <a:buFontTx/>
-              <a:buNone/>
-              <a:tabLst/>
-              <a:defRPr/>
-            </a:pPr>
-            <a:endParaRPr kumimoji="0" lang="en-US" sz="1800" b="0" i="0" u="none" strike="noStrike" kern="1200" cap="none" spc="0" normalizeH="0" baseline="0" noProof="0">
-              <a:ln>
-                <a:noFill/>
-              </a:ln>
-              <a:solidFill>
-                <a:prstClr val="white"/>
-              </a:solidFill>
-              <a:effectLst/>
-              <a:uLnTx/>
-              <a:uFillTx/>
-              <a:latin typeface="Calibri" panose="020F0502020204030204"/>
-              <a:ea typeface="+mn-ea"/>
-              <a:cs typeface="+mn-cs"/>
-            </a:endParaRPr>
-          </a:p>
-        </p:txBody>
-      </p:sp>
-      <p:sp>
-        <p:nvSpPr>
-          <p:cNvPr id="2" name="Title 1">
-            <a:extLst>
-              <a:ext uri="{FF2B5EF4-FFF2-40B4-BE49-F238E27FC236}">
-                <a16:creationId xmlns:a16="http://schemas.microsoft.com/office/drawing/2014/main" id="{7523CF74-09B7-84B3-F859-D7073DC1C80F}"/>
-              </a:ext>
-            </a:extLst>
-          </p:cNvPr>
-          <p:cNvSpPr>
-            <a:spLocks noGrp="1"/>
-          </p:cNvSpPr>
-          <p:nvPr>
-            <p:ph type="title"/>
-          </p:nvPr>
-        </p:nvSpPr>
-        <p:spPr>
-          <a:xfrm>
-            <a:off x="2103121" y="310343"/>
-            <a:ext cx="7985759" cy="868823"/>
-          </a:xfrm>
-        </p:spPr>
-        <p:txBody>
-          <a:bodyPr vert="horz" lIns="91440" tIns="45720" rIns="91440" bIns="45720" rtlCol="0" anchor="ctr">
-            <a:normAutofit/>
-          </a:bodyPr>
-          <a:lstStyle/>
-          <a:p>
-            <a:pPr algn="ctr"/>
-            <a:r>
-              <a:rPr lang="en-US" sz="4000" kern="1200">
-                <a:solidFill>
-                  <a:schemeClr val="tx1"/>
-                </a:solidFill>
-                <a:latin typeface="+mj-lt"/>
-                <a:ea typeface="+mj-ea"/>
-                <a:cs typeface="+mj-cs"/>
-              </a:rPr>
-              <a:t>Planning</a:t>
-            </a:r>
-          </a:p>
-        </p:txBody>
-      </p:sp>
-      <p:sp>
-        <p:nvSpPr>
-          <p:cNvPr id="32" name="Rectangle: Rounded Corners 31">
-            <a:extLst>
-              <a:ext uri="{FF2B5EF4-FFF2-40B4-BE49-F238E27FC236}">
-                <a16:creationId xmlns:a16="http://schemas.microsoft.com/office/drawing/2014/main" id="{586B4EF9-43BA-4655-A6FF-1D8E21574C95}"/>
-              </a:ext>
-              <a:ext uri="{C183D7F6-B498-43B3-948B-1728B52AA6E4}">
-                <adec:decorative xmlns:adec="http://schemas.microsoft.com/office/drawing/2017/decorative" val="1"/>
-              </a:ext>
-            </a:extLst>
-          </p:cNvPr>
-          <p:cNvSpPr>
-            <a:spLocks noGrp="1" noRot="1" noChangeAspect="1" noMove="1" noResize="1" noEditPoints="1" noAdjustHandles="1" noChangeArrowheads="1" noChangeShapeType="1" noTextEdit="1"/>
-          </p:cNvSpPr>
-          <p:nvPr>
-            <p:extLst>
-              <p:ext uri="{386F3935-93C4-4BCD-93E2-E3B085C9AB24}">
-                <p16:designElem xmlns:p16="http://schemas.microsoft.com/office/powerpoint/2015/main" val="1"/>
-              </p:ext>
-            </p:extLst>
-          </p:nvPr>
-        </p:nvSpPr>
-        <p:spPr>
-          <a:xfrm>
-            <a:off x="2483110" y="1211407"/>
-            <a:ext cx="7225780" cy="685800"/>
-          </a:xfrm>
-          <a:prstGeom prst="roundRect">
-            <a:avLst>
-              <a:gd name="adj" fmla="val 0"/>
-            </a:avLst>
-          </a:prstGeom>
-          <a:solidFill>
-            <a:schemeClr val="accent2"/>
-          </a:solidFill>
+          <a:gradFill>
+            <a:gsLst>
+              <a:gs pos="0">
+                <a:schemeClr val="accent1">
+                  <a:alpha val="50000"/>
+                </a:schemeClr>
+              </a:gs>
+              <a:gs pos="100000">
+                <a:schemeClr val="accent1">
+                  <a:lumMod val="50000"/>
+                  <a:alpha val="0"/>
+                </a:schemeClr>
+              </a:gs>
+            </a:gsLst>
+            <a:lin ang="11400000" scaled="0"/>
+          </a:gradFill>
           <a:ln>
             <a:noFill/>
           </a:ln>
@@ -16812,21 +18316,264 @@
           <a:lstStyle/>
           <a:p>
             <a:pPr algn="ctr"/>
-            <a:endParaRPr lang="en-US">
-              <a:solidFill>
-                <a:prstClr val="white"/>
-              </a:solidFill>
-              <a:latin typeface="Calibri" panose="020F0502020204030204"/>
-            </a:endParaRPr>
+            <a:endParaRPr lang="en-US"/>
           </a:p>
         </p:txBody>
       </p:sp>
       <p:sp>
         <p:nvSpPr>
-          <p:cNvPr id="3" name="Text Placeholder 2">
+          <p:cNvPr id="29" name="Rectangle 28">
             <a:extLst>
               <a:ext uri="{FF2B5EF4-FFF2-40B4-BE49-F238E27FC236}">
-                <a16:creationId xmlns:a16="http://schemas.microsoft.com/office/drawing/2014/main" id="{C605E30C-3490-D1E3-740D-40AD5E393958}"/>
+                <a16:creationId xmlns:a16="http://schemas.microsoft.com/office/drawing/2014/main" id="{85149191-5F60-4A28-AAFF-039F96B0F3EC}"/>
+              </a:ext>
+              <a:ext uri="{C183D7F6-B498-43B3-948B-1728B52AA6E4}">
+                <adec:decorative xmlns:adec="http://schemas.microsoft.com/office/drawing/2017/decorative" val="1"/>
+              </a:ext>
+            </a:extLst>
+          </p:cNvPr>
+          <p:cNvSpPr>
+            <a:spLocks noGrp="1" noRot="1" noChangeAspect="1" noMove="1" noResize="1" noEditPoints="1" noAdjustHandles="1" noChangeArrowheads="1" noChangeShapeType="1" noTextEdit="1"/>
+          </p:cNvSpPr>
+          <p:nvPr>
+            <p:extLst>
+              <p:ext uri="{386F3935-93C4-4BCD-93E2-E3B085C9AB24}">
+                <p16:designElem xmlns:p16="http://schemas.microsoft.com/office/powerpoint/2015/main" val="1"/>
+              </p:ext>
+            </p:extLst>
+          </p:nvPr>
+        </p:nvSpPr>
+        <p:spPr>
+          <a:xfrm rot="16200000" flipH="1">
+            <a:off x="-1180882" y="1638085"/>
+            <a:ext cx="6857572" cy="3581401"/>
+          </a:xfrm>
+          <a:prstGeom prst="rect">
+            <a:avLst/>
+          </a:prstGeom>
+          <a:gradFill>
+            <a:gsLst>
+              <a:gs pos="0">
+                <a:srgbClr val="000000">
+                  <a:alpha val="59000"/>
+                </a:srgbClr>
+              </a:gs>
+              <a:gs pos="69000">
+                <a:schemeClr val="accent1">
+                  <a:alpha val="0"/>
+                </a:schemeClr>
+              </a:gs>
+            </a:gsLst>
+            <a:lin ang="13200000" scaled="0"/>
+          </a:gradFill>
+          <a:ln>
+            <a:noFill/>
+          </a:ln>
+        </p:spPr>
+        <p:style>
+          <a:lnRef idx="2">
+            <a:schemeClr val="accent1">
+              <a:shade val="50000"/>
+            </a:schemeClr>
+          </a:lnRef>
+          <a:fillRef idx="1">
+            <a:schemeClr val="accent1"/>
+          </a:fillRef>
+          <a:effectRef idx="0">
+            <a:schemeClr val="accent1"/>
+          </a:effectRef>
+          <a:fontRef idx="minor">
+            <a:schemeClr val="lt1"/>
+          </a:fontRef>
+        </p:style>
+        <p:txBody>
+          <a:bodyPr rtlCol="0" anchor="ctr"/>
+          <a:lstStyle/>
+          <a:p>
+            <a:pPr algn="ctr"/>
+            <a:endParaRPr lang="en-US" dirty="0"/>
+          </a:p>
+        </p:txBody>
+      </p:sp>
+      <p:sp>
+        <p:nvSpPr>
+          <p:cNvPr id="31" name="Freeform: Shape 30">
+            <a:extLst>
+              <a:ext uri="{FF2B5EF4-FFF2-40B4-BE49-F238E27FC236}">
+                <a16:creationId xmlns:a16="http://schemas.microsoft.com/office/drawing/2014/main" id="{F8260ED5-17F7-4158-B241-D51DD4CF1B7E}"/>
+              </a:ext>
+              <a:ext uri="{C183D7F6-B498-43B3-948B-1728B52AA6E4}">
+                <adec:decorative xmlns:adec="http://schemas.microsoft.com/office/drawing/2017/decorative" val="1"/>
+              </a:ext>
+            </a:extLst>
+          </p:cNvPr>
+          <p:cNvSpPr>
+            <a:spLocks noGrp="1" noRot="1" noChangeAspect="1" noMove="1" noResize="1" noEditPoints="1" noAdjustHandles="1" noChangeArrowheads="1" noChangeShapeType="1" noTextEdit="1"/>
+          </p:cNvSpPr>
+          <p:nvPr>
+            <p:extLst>
+              <p:ext uri="{386F3935-93C4-4BCD-93E2-E3B085C9AB24}">
+                <p16:designElem xmlns:p16="http://schemas.microsoft.com/office/powerpoint/2015/main" val="1"/>
+              </p:ext>
+            </p:extLst>
+          </p:nvPr>
+        </p:nvSpPr>
+        <p:spPr>
+          <a:xfrm rot="6097846">
+            <a:off x="-747355" y="1201312"/>
+            <a:ext cx="4808302" cy="4088666"/>
+          </a:xfrm>
+          <a:custGeom>
+            <a:avLst/>
+            <a:gdLst>
+              <a:gd name="connsiteX0" fmla="*/ 48844 w 4808302"/>
+              <a:gd name="connsiteY0" fmla="*/ 2888671 h 4088666"/>
+              <a:gd name="connsiteX1" fmla="*/ 0 w 4808302"/>
+              <a:gd name="connsiteY1" fmla="*/ 2404151 h 4088666"/>
+              <a:gd name="connsiteX2" fmla="*/ 2404151 w 4808302"/>
+              <a:gd name="connsiteY2" fmla="*/ 0 h 4088666"/>
+              <a:gd name="connsiteX3" fmla="*/ 4808302 w 4808302"/>
+              <a:gd name="connsiteY3" fmla="*/ 2404151 h 4088666"/>
+              <a:gd name="connsiteX4" fmla="*/ 4700216 w 4808302"/>
+              <a:gd name="connsiteY4" fmla="*/ 3119072 h 4088666"/>
+              <a:gd name="connsiteX5" fmla="*/ 4643143 w 4808302"/>
+              <a:gd name="connsiteY5" fmla="*/ 3275009 h 4088666"/>
+              <a:gd name="connsiteX6" fmla="*/ 690093 w 4808302"/>
+              <a:gd name="connsiteY6" fmla="*/ 4088666 h 4088666"/>
+              <a:gd name="connsiteX7" fmla="*/ 548991 w 4808302"/>
+              <a:gd name="connsiteY7" fmla="*/ 3933414 h 4088666"/>
+              <a:gd name="connsiteX8" fmla="*/ 48844 w 4808302"/>
+              <a:gd name="connsiteY8" fmla="*/ 2888671 h 4088666"/>
+            </a:gdLst>
+            <a:ahLst/>
+            <a:cxnLst>
+              <a:cxn ang="0">
+                <a:pos x="connsiteX0" y="connsiteY0"/>
+              </a:cxn>
+              <a:cxn ang="0">
+                <a:pos x="connsiteX1" y="connsiteY1"/>
+              </a:cxn>
+              <a:cxn ang="0">
+                <a:pos x="connsiteX2" y="connsiteY2"/>
+              </a:cxn>
+              <a:cxn ang="0">
+                <a:pos x="connsiteX3" y="connsiteY3"/>
+              </a:cxn>
+              <a:cxn ang="0">
+                <a:pos x="connsiteX4" y="connsiteY4"/>
+              </a:cxn>
+              <a:cxn ang="0">
+                <a:pos x="connsiteX5" y="connsiteY5"/>
+              </a:cxn>
+              <a:cxn ang="0">
+                <a:pos x="connsiteX6" y="connsiteY6"/>
+              </a:cxn>
+              <a:cxn ang="0">
+                <a:pos x="connsiteX7" y="connsiteY7"/>
+              </a:cxn>
+              <a:cxn ang="0">
+                <a:pos x="connsiteX8" y="connsiteY8"/>
+              </a:cxn>
+            </a:cxnLst>
+            <a:rect l="l" t="t" r="r" b="b"/>
+            <a:pathLst>
+              <a:path w="4808302" h="4088666">
+                <a:moveTo>
+                  <a:pt x="48844" y="2888671"/>
+                </a:moveTo>
+                <a:cubicBezTo>
+                  <a:pt x="16818" y="2732167"/>
+                  <a:pt x="0" y="2570123"/>
+                  <a:pt x="0" y="2404151"/>
+                </a:cubicBezTo>
+                <a:cubicBezTo>
+                  <a:pt x="0" y="1076375"/>
+                  <a:pt x="1076375" y="0"/>
+                  <a:pt x="2404151" y="0"/>
+                </a:cubicBezTo>
+                <a:cubicBezTo>
+                  <a:pt x="3731927" y="0"/>
+                  <a:pt x="4808302" y="1076375"/>
+                  <a:pt x="4808302" y="2404151"/>
+                </a:cubicBezTo>
+                <a:cubicBezTo>
+                  <a:pt x="4808302" y="2653109"/>
+                  <a:pt x="4770461" y="2893229"/>
+                  <a:pt x="4700216" y="3119072"/>
+                </a:cubicBezTo>
+                <a:lnTo>
+                  <a:pt x="4643143" y="3275009"/>
+                </a:lnTo>
+                <a:lnTo>
+                  <a:pt x="690093" y="4088666"/>
+                </a:lnTo>
+                <a:lnTo>
+                  <a:pt x="548991" y="3933414"/>
+                </a:lnTo>
+                <a:cubicBezTo>
+                  <a:pt x="304015" y="3636572"/>
+                  <a:pt x="128908" y="3279932"/>
+                  <a:pt x="48844" y="2888671"/>
+                </a:cubicBezTo>
+                <a:close/>
+              </a:path>
+            </a:pathLst>
+          </a:custGeom>
+          <a:gradFill>
+            <a:gsLst>
+              <a:gs pos="39000">
+                <a:schemeClr val="accent1">
+                  <a:lumMod val="60000"/>
+                  <a:lumOff val="40000"/>
+                  <a:alpha val="0"/>
+                </a:schemeClr>
+              </a:gs>
+              <a:gs pos="100000">
+                <a:schemeClr val="accent1">
+                  <a:lumMod val="75000"/>
+                  <a:alpha val="26000"/>
+                </a:schemeClr>
+              </a:gs>
+            </a:gsLst>
+            <a:lin ang="18600000" scaled="0"/>
+          </a:gradFill>
+          <a:ln>
+            <a:noFill/>
+          </a:ln>
+        </p:spPr>
+        <p:style>
+          <a:lnRef idx="2">
+            <a:schemeClr val="accent1">
+              <a:shade val="50000"/>
+            </a:schemeClr>
+          </a:lnRef>
+          <a:fillRef idx="1">
+            <a:schemeClr val="accent1"/>
+          </a:fillRef>
+          <a:effectRef idx="0">
+            <a:schemeClr val="accent1"/>
+          </a:effectRef>
+          <a:fontRef idx="minor">
+            <a:schemeClr val="lt1"/>
+          </a:fontRef>
+        </p:style>
+        <p:txBody>
+          <a:bodyPr wrap="square" rtlCol="0" anchor="ctr">
+            <a:noAutofit/>
+          </a:bodyPr>
+          <a:lstStyle/>
+          <a:p>
+            <a:pPr algn="ctr"/>
+            <a:endParaRPr lang="en-US" dirty="0"/>
+          </a:p>
+        </p:txBody>
+      </p:sp>
+      <p:sp>
+        <p:nvSpPr>
+          <p:cNvPr id="2" name="Title 1">
+            <a:extLst>
+              <a:ext uri="{FF2B5EF4-FFF2-40B4-BE49-F238E27FC236}">
+                <a16:creationId xmlns:a16="http://schemas.microsoft.com/office/drawing/2014/main" id="{287294F0-C177-B508-EF76-D3B280BC1128}"/>
               </a:ext>
             </a:extLst>
           </p:cNvPr>
@@ -16834,76 +18581,71 @@
             <a:spLocks noGrp="1"/>
           </p:cNvSpPr>
           <p:nvPr>
-            <p:ph type="body" idx="1"/>
+            <p:ph type="title"/>
           </p:nvPr>
         </p:nvSpPr>
         <p:spPr>
           <a:xfrm>
-            <a:off x="2615738" y="1263807"/>
-            <a:ext cx="6960524" cy="598516"/>
+            <a:off x="660041" y="2767106"/>
+            <a:ext cx="2880828" cy="3071906"/>
           </a:xfrm>
         </p:spPr>
         <p:txBody>
-          <a:bodyPr vert="horz" lIns="91440" tIns="45720" rIns="91440" bIns="45720" rtlCol="0" anchor="ctr">
+          <a:bodyPr vert="horz" lIns="91440" tIns="45720" rIns="91440" bIns="45720" rtlCol="0" anchor="t">
             <a:normAutofit/>
           </a:bodyPr>
           <a:lstStyle/>
           <a:p>
-            <a:pPr algn="ctr"/>
             <a:r>
-              <a:rPr lang="en-US" sz="2000" kern="1200">
+              <a:rPr lang="en-US" sz="3700" kern="1200">
                 <a:solidFill>
-                  <a:schemeClr val="bg1"/>
+                  <a:srgbClr val="FFFFFF"/>
                 </a:solidFill>
-                <a:latin typeface="+mn-lt"/>
-                <a:ea typeface="+mn-ea"/>
-                <a:cs typeface="+mn-cs"/>
+                <a:latin typeface="+mj-lt"/>
+                <a:ea typeface="+mj-ea"/>
+                <a:cs typeface="+mj-cs"/>
               </a:rPr>
-              <a:t>Gant chart</a:t>
+              <a:t>User Feedback Enhancement</a:t>
             </a:r>
           </a:p>
         </p:txBody>
       </p:sp>
       <p:pic>
         <p:nvPicPr>
-          <p:cNvPr id="5" name="Picture 4">
+          <p:cNvPr id="9" name="Content Placeholder 8">
             <a:extLst>
               <a:ext uri="{FF2B5EF4-FFF2-40B4-BE49-F238E27FC236}">
-                <a16:creationId xmlns:a16="http://schemas.microsoft.com/office/drawing/2014/main" id="{30D9BB01-16EE-371C-49E8-833A93D92451}"/>
+                <a16:creationId xmlns:a16="http://schemas.microsoft.com/office/drawing/2014/main" id="{D59BCB45-73D7-766D-FD59-D8B09BE25C52}"/>
               </a:ext>
             </a:extLst>
           </p:cNvPr>
           <p:cNvPicPr>
-            <a:picLocks noChangeAspect="1"/>
+            <a:picLocks noGrp="1" noChangeAspect="1"/>
           </p:cNvPicPr>
-          <p:nvPr/>
+          <p:nvPr>
+            <p:ph idx="1"/>
+          </p:nvPr>
         </p:nvPicPr>
         <p:blipFill>
           <a:blip r:embed="rId2"/>
-          <a:srcRect r="3514"/>
           <a:stretch>
             <a:fillRect/>
           </a:stretch>
         </p:blipFill>
         <p:spPr>
           <a:xfrm>
-            <a:off x="0" y="2219602"/>
-            <a:ext cx="12191999" cy="4608716"/>
+            <a:off x="6960203" y="467208"/>
+            <a:ext cx="2310197" cy="5923584"/>
           </a:xfrm>
           <a:prstGeom prst="rect">
             <a:avLst/>
           </a:prstGeom>
-          <a:ln w="28575">
-            <a:solidFill>
-              <a:schemeClr val="accent2"/>
-            </a:solidFill>
-          </a:ln>
         </p:spPr>
       </p:pic>
     </p:spTree>
     <p:extLst>
       <p:ext uri="{BB962C8B-B14F-4D97-AF65-F5344CB8AC3E}">
-        <p14:creationId xmlns:p14="http://schemas.microsoft.com/office/powerpoint/2010/main" val="3713997872"/>
+        <p14:creationId xmlns:p14="http://schemas.microsoft.com/office/powerpoint/2010/main" val="3967077253"/>
       </p:ext>
     </p:extLst>
   </p:cSld>

</xml_diff>